<commit_message>
Target AI Architecture deck v2.1 — diagrams, cost bands, roadmap
- Add a layered 'architecture at a glance' diagram slide per option (Users →
  Experience → Orchestration & skills → MCP → Intelligence → Data → Obs).
- Add an indicative cost-shape table and a phased-rollout roadmap slide.
- New 'layers' render kind across HTML/MD/PPTX. Version bumped to v2.1 (15 slides).

Co-Authored-By: Claude Opus 4.8 <noreply@anthropic.com>
</commit_message>
<xml_diff>
--- a/docs/jtcgroup_target_ai_architecture.pptx
+++ b/docs/jtcgroup_target_ai_architecture.pptx
@@ -16,6 +16,10 @@
     <p:sldId id="264" r:id="rId15"/>
     <p:sldId id="265" r:id="rId16"/>
     <p:sldId id="266" r:id="rId17"/>
+    <p:sldId id="267" r:id="rId18"/>
+    <p:sldId id="268" r:id="rId19"/>
+    <p:sldId id="269" r:id="rId20"/>
+    <p:sldId id="270" r:id="rId21"/>
   </p:sldIdLst>
   <p:sldSz cx="12191695" cy="6858000" type="screen4x3"/>
   <p:notesSz cx="6858000" cy="9144000"/>
@@ -3189,7 +3193,7 @@
                   <a:srgbClr val="FFFFFF"/>
                 </a:solidFill>
               </a:rPr>
-              <a:t>JTC Group · Target AI Architecture · v2.0</a:t>
+              <a:t>JTC Group · Target AI Architecture · v2.1</a:t>
             </a:r>
           </a:p>
         </p:txBody>
@@ -3282,7 +3286,7 @@
                   <a:srgbClr val="7A7A85"/>
                 </a:solidFill>
               </a:rPr>
-              <a:t>Reference architecture · v2.0 · Draft for review</a:t>
+              <a:t>Reference architecture · v2.1 · Draft for review</a:t>
             </a:r>
           </a:p>
         </p:txBody>
@@ -3396,7 +3400,1405 @@
                   <a:srgbClr val="FFFFFF"/>
                 </a:solidFill>
               </a:rPr>
-              <a:t>JTC Group · Target AI Architecture · v2.0</a:t>
+              <a:t>JTC Group · Target AI Architecture · v2.1</a:t>
+            </a:r>
+          </a:p>
+        </p:txBody>
+      </p:sp>
+      <p:sp>
+        <p:nvSpPr>
+          <p:cNvPr id="4" name="TextBox 3"/>
+          <p:cNvSpPr txBox="1"/>
+          <p:nvPr/>
+        </p:nvSpPr>
+        <p:spPr>
+          <a:xfrm>
+            <a:off x="457200" y="310896"/>
+            <a:ext cx="11247120" cy="822960"/>
+          </a:xfrm>
+          <a:prstGeom prst="rect">
+            <a:avLst/>
+          </a:prstGeom>
+          <a:noFill/>
+        </p:spPr>
+        <p:txBody>
+          <a:bodyPr wrap="none">
+            <a:spAutoFit/>
+          </a:bodyPr>
+          <a:lstStyle/>
+          <a:p>
+            <a:r>
+              <a:rPr sz="3000" b="1">
+                <a:solidFill>
+                  <a:srgbClr val="6B1766"/>
+                </a:solidFill>
+              </a:rPr>
+              <a:t>Option 2 — architecture at a glance</a:t>
+            </a:r>
+            <a:r>
+              <a:rPr sz="1300" b="1">
+                <a:solidFill>
+                  <a:srgbClr val="BA2A84"/>
+                </a:solidFill>
+              </a:rPr>
+              <a:t>   MS-MANAGED</a:t>
+            </a:r>
+          </a:p>
+        </p:txBody>
+      </p:sp>
+      <p:sp>
+        <p:nvSpPr>
+          <p:cNvPr id="5" name="TextBox 4"/>
+          <p:cNvSpPr txBox="1"/>
+          <p:nvPr/>
+        </p:nvSpPr>
+        <p:spPr>
+          <a:xfrm>
+            <a:off x="457200" y="1188720"/>
+            <a:ext cx="11247120" cy="5120640"/>
+          </a:xfrm>
+          <a:prstGeom prst="rect">
+            <a:avLst/>
+          </a:prstGeom>
+          <a:noFill/>
+        </p:spPr>
+        <p:txBody>
+          <a:bodyPr wrap="square">
+            <a:spAutoFit/>
+          </a:bodyPr>
+          <a:lstStyle/>
+          <a:p/>
+        </p:txBody>
+      </p:sp>
+      <p:sp>
+        <p:nvSpPr>
+          <p:cNvPr id="6" name="Rounded Rectangle 5"/>
+          <p:cNvSpPr/>
+          <p:nvPr/>
+        </p:nvSpPr>
+        <p:spPr>
+          <a:xfrm>
+            <a:off x="457200" y="1371600"/>
+            <a:ext cx="3063240" cy="566928"/>
+          </a:xfrm>
+          <a:prstGeom prst="roundRect">
+            <a:avLst/>
+          </a:prstGeom>
+          <a:solidFill>
+            <a:srgbClr val="550055"/>
+          </a:solidFill>
+          <a:ln>
+            <a:noFill/>
+          </a:ln>
+          <a:effectLst/>
+        </p:spPr>
+        <p:style>
+          <a:lnRef idx="1">
+            <a:schemeClr val="accent1"/>
+          </a:lnRef>
+          <a:fillRef idx="3">
+            <a:schemeClr val="accent1"/>
+          </a:fillRef>
+          <a:effectRef idx="2">
+            <a:schemeClr val="accent1"/>
+          </a:effectRef>
+          <a:fontRef idx="minor">
+            <a:schemeClr val="lt1"/>
+          </a:fontRef>
+        </p:style>
+        <p:txBody>
+          <a:bodyPr rtlCol="0" anchor="ctr" wrap="square" lIns="128016"/>
+          <a:lstStyle/>
+          <a:p>
+            <a:pPr algn="ctr"/>
+            <a:r>
+              <a:rPr sz="1300" b="1">
+                <a:solidFill>
+                  <a:srgbClr val="FFFFFF"/>
+                </a:solidFill>
+              </a:rPr>
+              <a:t>Users</a:t>
+            </a:r>
+          </a:p>
+        </p:txBody>
+      </p:sp>
+      <p:sp>
+        <p:nvSpPr>
+          <p:cNvPr id="7" name="Rounded Rectangle 6"/>
+          <p:cNvSpPr/>
+          <p:nvPr/>
+        </p:nvSpPr>
+        <p:spPr>
+          <a:xfrm>
+            <a:off x="3639312" y="1371600"/>
+            <a:ext cx="8092440" cy="566928"/>
+          </a:xfrm>
+          <a:prstGeom prst="roundRect">
+            <a:avLst/>
+          </a:prstGeom>
+          <a:solidFill>
+            <a:srgbClr val="F4EFF7"/>
+          </a:solidFill>
+          <a:ln w="6350">
+            <a:solidFill>
+              <a:srgbClr val="E6E3EC"/>
+            </a:solidFill>
+          </a:ln>
+          <a:effectLst/>
+        </p:spPr>
+        <p:style>
+          <a:lnRef idx="1">
+            <a:schemeClr val="accent1"/>
+          </a:lnRef>
+          <a:fillRef idx="3">
+            <a:schemeClr val="accent1"/>
+          </a:fillRef>
+          <a:effectRef idx="2">
+            <a:schemeClr val="accent1"/>
+          </a:effectRef>
+          <a:fontRef idx="minor">
+            <a:schemeClr val="lt1"/>
+          </a:fontRef>
+        </p:style>
+        <p:txBody>
+          <a:bodyPr rtlCol="0" anchor="ctr" wrap="square" lIns="146304"/>
+          <a:lstStyle/>
+          <a:p>
+            <a:pPr algn="ctr"/>
+            <a:r>
+              <a:rPr sz="1250">
+                <a:solidFill>
+                  <a:srgbClr val="48484F"/>
+                </a:solidFill>
+              </a:rPr>
+              <a:t>Back-office &amp; advisors · Entra ID SSO</a:t>
+            </a:r>
+          </a:p>
+        </p:txBody>
+      </p:sp>
+      <p:sp>
+        <p:nvSpPr>
+          <p:cNvPr id="8" name="Rounded Rectangle 7"/>
+          <p:cNvSpPr/>
+          <p:nvPr/>
+        </p:nvSpPr>
+        <p:spPr>
+          <a:xfrm>
+            <a:off x="457200" y="2020824"/>
+            <a:ext cx="3063240" cy="566928"/>
+          </a:xfrm>
+          <a:prstGeom prst="roundRect">
+            <a:avLst/>
+          </a:prstGeom>
+          <a:solidFill>
+            <a:srgbClr val="550055"/>
+          </a:solidFill>
+          <a:ln>
+            <a:noFill/>
+          </a:ln>
+          <a:effectLst/>
+        </p:spPr>
+        <p:style>
+          <a:lnRef idx="1">
+            <a:schemeClr val="accent1"/>
+          </a:lnRef>
+          <a:fillRef idx="3">
+            <a:schemeClr val="accent1"/>
+          </a:fillRef>
+          <a:effectRef idx="2">
+            <a:schemeClr val="accent1"/>
+          </a:effectRef>
+          <a:fontRef idx="minor">
+            <a:schemeClr val="lt1"/>
+          </a:fontRef>
+        </p:style>
+        <p:txBody>
+          <a:bodyPr rtlCol="0" anchor="ctr" wrap="square" lIns="128016"/>
+          <a:lstStyle/>
+          <a:p>
+            <a:pPr algn="ctr"/>
+            <a:r>
+              <a:rPr sz="1300" b="1">
+                <a:solidFill>
+                  <a:srgbClr val="FFFFFF"/>
+                </a:solidFill>
+              </a:rPr>
+              <a:t>Experience</a:t>
+            </a:r>
+          </a:p>
+        </p:txBody>
+      </p:sp>
+      <p:sp>
+        <p:nvSpPr>
+          <p:cNvPr id="9" name="Rounded Rectangle 8"/>
+          <p:cNvSpPr/>
+          <p:nvPr/>
+        </p:nvSpPr>
+        <p:spPr>
+          <a:xfrm>
+            <a:off x="3639312" y="2020824"/>
+            <a:ext cx="8092440" cy="566928"/>
+          </a:xfrm>
+          <a:prstGeom prst="roundRect">
+            <a:avLst/>
+          </a:prstGeom>
+          <a:solidFill>
+            <a:srgbClr val="F4EFF7"/>
+          </a:solidFill>
+          <a:ln w="6350">
+            <a:solidFill>
+              <a:srgbClr val="E6E3EC"/>
+            </a:solidFill>
+          </a:ln>
+          <a:effectLst/>
+        </p:spPr>
+        <p:style>
+          <a:lnRef idx="1">
+            <a:schemeClr val="accent1"/>
+          </a:lnRef>
+          <a:fillRef idx="3">
+            <a:schemeClr val="accent1"/>
+          </a:fillRef>
+          <a:effectRef idx="2">
+            <a:schemeClr val="accent1"/>
+          </a:effectRef>
+          <a:fontRef idx="minor">
+            <a:schemeClr val="lt1"/>
+          </a:fontRef>
+        </p:style>
+        <p:txBody>
+          <a:bodyPr rtlCol="0" anchor="ctr" wrap="square" lIns="146304"/>
+          <a:lstStyle/>
+          <a:p>
+            <a:pPr algn="ctr"/>
+            <a:r>
+              <a:rPr sz="1250">
+                <a:solidFill>
+                  <a:srgbClr val="48484F"/>
+                </a:solidFill>
+              </a:rPr>
+              <a:t>App / Microsoft Copilot surface</a:t>
+            </a:r>
+          </a:p>
+        </p:txBody>
+      </p:sp>
+      <p:sp>
+        <p:nvSpPr>
+          <p:cNvPr id="10" name="Rounded Rectangle 9"/>
+          <p:cNvSpPr/>
+          <p:nvPr/>
+        </p:nvSpPr>
+        <p:spPr>
+          <a:xfrm>
+            <a:off x="457200" y="2670048"/>
+            <a:ext cx="3063240" cy="566928"/>
+          </a:xfrm>
+          <a:prstGeom prst="roundRect">
+            <a:avLst/>
+          </a:prstGeom>
+          <a:solidFill>
+            <a:srgbClr val="550055"/>
+          </a:solidFill>
+          <a:ln>
+            <a:noFill/>
+          </a:ln>
+          <a:effectLst/>
+        </p:spPr>
+        <p:style>
+          <a:lnRef idx="1">
+            <a:schemeClr val="accent1"/>
+          </a:lnRef>
+          <a:fillRef idx="3">
+            <a:schemeClr val="accent1"/>
+          </a:fillRef>
+          <a:effectRef idx="2">
+            <a:schemeClr val="accent1"/>
+          </a:effectRef>
+          <a:fontRef idx="minor">
+            <a:schemeClr val="lt1"/>
+          </a:fontRef>
+        </p:style>
+        <p:txBody>
+          <a:bodyPr rtlCol="0" anchor="ctr" wrap="square" lIns="128016"/>
+          <a:lstStyle/>
+          <a:p>
+            <a:pPr algn="ctr"/>
+            <a:r>
+              <a:rPr sz="1300" b="1">
+                <a:solidFill>
+                  <a:srgbClr val="FFFFFF"/>
+                </a:solidFill>
+              </a:rPr>
+              <a:t>Orchestration &amp; skills</a:t>
+            </a:r>
+          </a:p>
+        </p:txBody>
+      </p:sp>
+      <p:sp>
+        <p:nvSpPr>
+          <p:cNvPr id="11" name="Rounded Rectangle 10"/>
+          <p:cNvSpPr/>
+          <p:nvPr/>
+        </p:nvSpPr>
+        <p:spPr>
+          <a:xfrm>
+            <a:off x="3639312" y="2670048"/>
+            <a:ext cx="8092440" cy="566928"/>
+          </a:xfrm>
+          <a:prstGeom prst="roundRect">
+            <a:avLst/>
+          </a:prstGeom>
+          <a:solidFill>
+            <a:srgbClr val="F4EFF7"/>
+          </a:solidFill>
+          <a:ln w="6350">
+            <a:solidFill>
+              <a:srgbClr val="E6E3EC"/>
+            </a:solidFill>
+          </a:ln>
+          <a:effectLst/>
+        </p:spPr>
+        <p:style>
+          <a:lnRef idx="1">
+            <a:schemeClr val="accent1"/>
+          </a:lnRef>
+          <a:fillRef idx="3">
+            <a:schemeClr val="accent1"/>
+          </a:fillRef>
+          <a:effectRef idx="2">
+            <a:schemeClr val="accent1"/>
+          </a:effectRef>
+          <a:fontRef idx="minor">
+            <a:schemeClr val="lt1"/>
+          </a:fontRef>
+        </p:style>
+        <p:txBody>
+          <a:bodyPr rtlCol="0" anchor="ctr" wrap="square" lIns="146304"/>
+          <a:lstStyle/>
+          <a:p>
+            <a:pPr algn="ctr"/>
+            <a:r>
+              <a:rPr sz="1250">
+                <a:solidFill>
+                  <a:srgbClr val="48484F"/>
+                </a:solidFill>
+              </a:rPr>
+              <a:t>Foundry Agent Service — managed + connected agents (skill packs)</a:t>
+            </a:r>
+          </a:p>
+        </p:txBody>
+      </p:sp>
+      <p:sp>
+        <p:nvSpPr>
+          <p:cNvPr id="12" name="Rounded Rectangle 11"/>
+          <p:cNvSpPr/>
+          <p:nvPr/>
+        </p:nvSpPr>
+        <p:spPr>
+          <a:xfrm>
+            <a:off x="457200" y="3319272"/>
+            <a:ext cx="3063240" cy="566928"/>
+          </a:xfrm>
+          <a:prstGeom prst="roundRect">
+            <a:avLst/>
+          </a:prstGeom>
+          <a:solidFill>
+            <a:srgbClr val="550055"/>
+          </a:solidFill>
+          <a:ln>
+            <a:noFill/>
+          </a:ln>
+          <a:effectLst/>
+        </p:spPr>
+        <p:style>
+          <a:lnRef idx="1">
+            <a:schemeClr val="accent1"/>
+          </a:lnRef>
+          <a:fillRef idx="3">
+            <a:schemeClr val="accent1"/>
+          </a:fillRef>
+          <a:effectRef idx="2">
+            <a:schemeClr val="accent1"/>
+          </a:effectRef>
+          <a:fontRef idx="minor">
+            <a:schemeClr val="lt1"/>
+          </a:fontRef>
+        </p:style>
+        <p:txBody>
+          <a:bodyPr rtlCol="0" anchor="ctr" wrap="square" lIns="128016"/>
+          <a:lstStyle/>
+          <a:p>
+            <a:pPr algn="ctr"/>
+            <a:r>
+              <a:rPr sz="1300" b="1">
+                <a:solidFill>
+                  <a:srgbClr val="FFFFFF"/>
+                </a:solidFill>
+              </a:rPr>
+              <a:t>Tools &amp; data (MCP)</a:t>
+            </a:r>
+          </a:p>
+        </p:txBody>
+      </p:sp>
+      <p:sp>
+        <p:nvSpPr>
+          <p:cNvPr id="13" name="Rounded Rectangle 12"/>
+          <p:cNvSpPr/>
+          <p:nvPr/>
+        </p:nvSpPr>
+        <p:spPr>
+          <a:xfrm>
+            <a:off x="3639312" y="3319272"/>
+            <a:ext cx="8092440" cy="566928"/>
+          </a:xfrm>
+          <a:prstGeom prst="roundRect">
+            <a:avLst/>
+          </a:prstGeom>
+          <a:solidFill>
+            <a:srgbClr val="F4EFF7"/>
+          </a:solidFill>
+          <a:ln w="6350">
+            <a:solidFill>
+              <a:srgbClr val="E6E3EC"/>
+            </a:solidFill>
+          </a:ln>
+          <a:effectLst/>
+        </p:spPr>
+        <p:style>
+          <a:lnRef idx="1">
+            <a:schemeClr val="accent1"/>
+          </a:lnRef>
+          <a:fillRef idx="3">
+            <a:schemeClr val="accent1"/>
+          </a:fillRef>
+          <a:effectRef idx="2">
+            <a:schemeClr val="accent1"/>
+          </a:effectRef>
+          <a:fontRef idx="minor">
+            <a:schemeClr val="lt1"/>
+          </a:fontRef>
+        </p:style>
+        <p:txBody>
+          <a:bodyPr rtlCol="0" anchor="ctr" wrap="square" lIns="146304"/>
+          <a:lstStyle/>
+          <a:p>
+            <a:pPr algn="ctr"/>
+            <a:r>
+              <a:rPr sz="1250">
+                <a:solidFill>
+                  <a:srgbClr val="48484F"/>
+                </a:solidFill>
+              </a:rPr>
+              <a:t>MCP tools in Foundry · Azure AI Search (RAG)</a:t>
+            </a:r>
+          </a:p>
+        </p:txBody>
+      </p:sp>
+      <p:sp>
+        <p:nvSpPr>
+          <p:cNvPr id="14" name="Rounded Rectangle 13"/>
+          <p:cNvSpPr/>
+          <p:nvPr/>
+        </p:nvSpPr>
+        <p:spPr>
+          <a:xfrm>
+            <a:off x="457200" y="3968496"/>
+            <a:ext cx="3063240" cy="566928"/>
+          </a:xfrm>
+          <a:prstGeom prst="roundRect">
+            <a:avLst/>
+          </a:prstGeom>
+          <a:solidFill>
+            <a:srgbClr val="550055"/>
+          </a:solidFill>
+          <a:ln>
+            <a:noFill/>
+          </a:ln>
+          <a:effectLst/>
+        </p:spPr>
+        <p:style>
+          <a:lnRef idx="1">
+            <a:schemeClr val="accent1"/>
+          </a:lnRef>
+          <a:fillRef idx="3">
+            <a:schemeClr val="accent1"/>
+          </a:fillRef>
+          <a:effectRef idx="2">
+            <a:schemeClr val="accent1"/>
+          </a:effectRef>
+          <a:fontRef idx="minor">
+            <a:schemeClr val="lt1"/>
+          </a:fontRef>
+        </p:style>
+        <p:txBody>
+          <a:bodyPr rtlCol="0" anchor="ctr" wrap="square" lIns="128016"/>
+          <a:lstStyle/>
+          <a:p>
+            <a:pPr algn="ctr"/>
+            <a:r>
+              <a:rPr sz="1300" b="1">
+                <a:solidFill>
+                  <a:srgbClr val="FFFFFF"/>
+                </a:solidFill>
+              </a:rPr>
+              <a:t>Intelligence</a:t>
+            </a:r>
+          </a:p>
+        </p:txBody>
+      </p:sp>
+      <p:sp>
+        <p:nvSpPr>
+          <p:cNvPr id="15" name="Rounded Rectangle 14"/>
+          <p:cNvSpPr/>
+          <p:nvPr/>
+        </p:nvSpPr>
+        <p:spPr>
+          <a:xfrm>
+            <a:off x="3639312" y="3968496"/>
+            <a:ext cx="8092440" cy="566928"/>
+          </a:xfrm>
+          <a:prstGeom prst="roundRect">
+            <a:avLst/>
+          </a:prstGeom>
+          <a:solidFill>
+            <a:srgbClr val="F4EFF7"/>
+          </a:solidFill>
+          <a:ln w="6350">
+            <a:solidFill>
+              <a:srgbClr val="E6E3EC"/>
+            </a:solidFill>
+          </a:ln>
+          <a:effectLst/>
+        </p:spPr>
+        <p:style>
+          <a:lnRef idx="1">
+            <a:schemeClr val="accent1"/>
+          </a:lnRef>
+          <a:fillRef idx="3">
+            <a:schemeClr val="accent1"/>
+          </a:fillRef>
+          <a:effectRef idx="2">
+            <a:schemeClr val="accent1"/>
+          </a:effectRef>
+          <a:fontRef idx="minor">
+            <a:schemeClr val="lt1"/>
+          </a:fontRef>
+        </p:style>
+        <p:txBody>
+          <a:bodyPr rtlCol="0" anchor="ctr" wrap="square" lIns="146304"/>
+          <a:lstStyle/>
+          <a:p>
+            <a:pPr algn="ctr"/>
+            <a:r>
+              <a:rPr sz="1250">
+                <a:solidFill>
+                  <a:srgbClr val="48484F"/>
+                </a:solidFill>
+              </a:rPr>
+              <a:t>Azure OpenAI — Anthropic Claude available via catalog</a:t>
+            </a:r>
+          </a:p>
+        </p:txBody>
+      </p:sp>
+      <p:sp>
+        <p:nvSpPr>
+          <p:cNvPr id="16" name="Rounded Rectangle 15"/>
+          <p:cNvSpPr/>
+          <p:nvPr/>
+        </p:nvSpPr>
+        <p:spPr>
+          <a:xfrm>
+            <a:off x="457200" y="4617720"/>
+            <a:ext cx="3063240" cy="566928"/>
+          </a:xfrm>
+          <a:prstGeom prst="roundRect">
+            <a:avLst/>
+          </a:prstGeom>
+          <a:solidFill>
+            <a:srgbClr val="550055"/>
+          </a:solidFill>
+          <a:ln>
+            <a:noFill/>
+          </a:ln>
+          <a:effectLst/>
+        </p:spPr>
+        <p:style>
+          <a:lnRef idx="1">
+            <a:schemeClr val="accent1"/>
+          </a:lnRef>
+          <a:fillRef idx="3">
+            <a:schemeClr val="accent1"/>
+          </a:fillRef>
+          <a:effectRef idx="2">
+            <a:schemeClr val="accent1"/>
+          </a:effectRef>
+          <a:fontRef idx="minor">
+            <a:schemeClr val="lt1"/>
+          </a:fontRef>
+        </p:style>
+        <p:txBody>
+          <a:bodyPr rtlCol="0" anchor="ctr" wrap="square" lIns="128016"/>
+          <a:lstStyle/>
+          <a:p>
+            <a:pPr algn="ctr"/>
+            <a:r>
+              <a:rPr sz="1300" b="1">
+                <a:solidFill>
+                  <a:srgbClr val="FFFFFF"/>
+                </a:solidFill>
+              </a:rPr>
+              <a:t>Data &amp; analytics</a:t>
+            </a:r>
+          </a:p>
+        </p:txBody>
+      </p:sp>
+      <p:sp>
+        <p:nvSpPr>
+          <p:cNvPr id="17" name="Rounded Rectangle 16"/>
+          <p:cNvSpPr/>
+          <p:nvPr/>
+        </p:nvSpPr>
+        <p:spPr>
+          <a:xfrm>
+            <a:off x="3639312" y="4617720"/>
+            <a:ext cx="8092440" cy="566928"/>
+          </a:xfrm>
+          <a:prstGeom prst="roundRect">
+            <a:avLst/>
+          </a:prstGeom>
+          <a:solidFill>
+            <a:srgbClr val="F4EFF7"/>
+          </a:solidFill>
+          <a:ln w="6350">
+            <a:solidFill>
+              <a:srgbClr val="E6E3EC"/>
+            </a:solidFill>
+          </a:ln>
+          <a:effectLst/>
+        </p:spPr>
+        <p:style>
+          <a:lnRef idx="1">
+            <a:schemeClr val="accent1"/>
+          </a:lnRef>
+          <a:fillRef idx="3">
+            <a:schemeClr val="accent1"/>
+          </a:fillRef>
+          <a:effectRef idx="2">
+            <a:schemeClr val="accent1"/>
+          </a:effectRef>
+          <a:fontRef idx="minor">
+            <a:schemeClr val="lt1"/>
+          </a:fontRef>
+        </p:style>
+        <p:txBody>
+          <a:bodyPr rtlCol="0" anchor="ctr" wrap="square" lIns="146304"/>
+          <a:lstStyle/>
+          <a:p>
+            <a:pPr algn="ctr"/>
+            <a:r>
+              <a:rPr sz="1250">
+                <a:solidFill>
+                  <a:srgbClr val="48484F"/>
+                </a:solidFill>
+              </a:rPr>
+              <a:t>Microsoft Fabric (OneLake) · Power BI</a:t>
+            </a:r>
+          </a:p>
+        </p:txBody>
+      </p:sp>
+      <p:sp>
+        <p:nvSpPr>
+          <p:cNvPr id="18" name="Rounded Rectangle 17"/>
+          <p:cNvSpPr/>
+          <p:nvPr/>
+        </p:nvSpPr>
+        <p:spPr>
+          <a:xfrm>
+            <a:off x="457200" y="5266944"/>
+            <a:ext cx="3063240" cy="566928"/>
+          </a:xfrm>
+          <a:prstGeom prst="roundRect">
+            <a:avLst/>
+          </a:prstGeom>
+          <a:solidFill>
+            <a:srgbClr val="550055"/>
+          </a:solidFill>
+          <a:ln>
+            <a:noFill/>
+          </a:ln>
+          <a:effectLst/>
+        </p:spPr>
+        <p:style>
+          <a:lnRef idx="1">
+            <a:schemeClr val="accent1"/>
+          </a:lnRef>
+          <a:fillRef idx="3">
+            <a:schemeClr val="accent1"/>
+          </a:fillRef>
+          <a:effectRef idx="2">
+            <a:schemeClr val="accent1"/>
+          </a:effectRef>
+          <a:fontRef idx="minor">
+            <a:schemeClr val="lt1"/>
+          </a:fontRef>
+        </p:style>
+        <p:txBody>
+          <a:bodyPr rtlCol="0" anchor="ctr" wrap="square" lIns="128016"/>
+          <a:lstStyle/>
+          <a:p>
+            <a:pPr algn="ctr"/>
+            <a:r>
+              <a:rPr sz="1300" b="1">
+                <a:solidFill>
+                  <a:srgbClr val="FFFFFF"/>
+                </a:solidFill>
+              </a:rPr>
+              <a:t>Governance &amp; obs</a:t>
+            </a:r>
+          </a:p>
+        </p:txBody>
+      </p:sp>
+      <p:sp>
+        <p:nvSpPr>
+          <p:cNvPr id="19" name="Rounded Rectangle 18"/>
+          <p:cNvSpPr/>
+          <p:nvPr/>
+        </p:nvSpPr>
+        <p:spPr>
+          <a:xfrm>
+            <a:off x="3639312" y="5266944"/>
+            <a:ext cx="8092440" cy="566928"/>
+          </a:xfrm>
+          <a:prstGeom prst="roundRect">
+            <a:avLst/>
+          </a:prstGeom>
+          <a:solidFill>
+            <a:srgbClr val="F4EFF7"/>
+          </a:solidFill>
+          <a:ln w="6350">
+            <a:solidFill>
+              <a:srgbClr val="E6E3EC"/>
+            </a:solidFill>
+          </a:ln>
+          <a:effectLst/>
+        </p:spPr>
+        <p:style>
+          <a:lnRef idx="1">
+            <a:schemeClr val="accent1"/>
+          </a:lnRef>
+          <a:fillRef idx="3">
+            <a:schemeClr val="accent1"/>
+          </a:fillRef>
+          <a:effectRef idx="2">
+            <a:schemeClr val="accent1"/>
+          </a:effectRef>
+          <a:fontRef idx="minor">
+            <a:schemeClr val="lt1"/>
+          </a:fontRef>
+        </p:style>
+        <p:txBody>
+          <a:bodyPr rtlCol="0" anchor="ctr" wrap="square" lIns="146304"/>
+          <a:lstStyle/>
+          <a:p>
+            <a:pPr algn="ctr"/>
+            <a:r>
+              <a:rPr sz="1250">
+                <a:solidFill>
+                  <a:srgbClr val="48484F"/>
+                </a:solidFill>
+              </a:rPr>
+              <a:t>Microsoft Purview · Azure Monitor + Foundry evals</a:t>
+            </a:r>
+          </a:p>
+        </p:txBody>
+      </p:sp>
+    </p:spTree>
+  </p:cSld>
+  <p:clrMapOvr>
+    <a:masterClrMapping/>
+  </p:clrMapOvr>
+</p:sld>
+</file>
+
+<file path=ppt/slides/slide11.xml><?xml version="1.0" encoding="utf-8"?>
+<p:sld xmlns:a="http://schemas.openxmlformats.org/drawingml/2006/main" xmlns:p="http://schemas.openxmlformats.org/presentationml/2006/main" xmlns:r="http://schemas.openxmlformats.org/officeDocument/2006/relationships">
+  <p:cSld>
+    <p:spTree>
+      <p:nvGrpSpPr>
+        <p:cNvPr id="1" name=""/>
+        <p:cNvGrpSpPr/>
+        <p:nvPr/>
+      </p:nvGrpSpPr>
+      <p:grpSpPr/>
+      <p:sp>
+        <p:nvSpPr>
+          <p:cNvPr id="2" name="Rectangle 1"/>
+          <p:cNvSpPr/>
+          <p:nvPr/>
+        </p:nvSpPr>
+        <p:spPr>
+          <a:xfrm>
+            <a:off x="0" y="0"/>
+            <a:ext cx="12191695" cy="146304"/>
+          </a:xfrm>
+          <a:prstGeom prst="rect">
+            <a:avLst/>
+          </a:prstGeom>
+          <a:solidFill>
+            <a:srgbClr val="550055"/>
+          </a:solidFill>
+          <a:ln>
+            <a:noFill/>
+          </a:ln>
+          <a:effectLst/>
+        </p:spPr>
+        <p:style>
+          <a:lnRef idx="1">
+            <a:schemeClr val="accent1"/>
+          </a:lnRef>
+          <a:fillRef idx="3">
+            <a:schemeClr val="accent1"/>
+          </a:fillRef>
+          <a:effectRef idx="2">
+            <a:schemeClr val="accent1"/>
+          </a:effectRef>
+          <a:fontRef idx="minor">
+            <a:schemeClr val="lt1"/>
+          </a:fontRef>
+        </p:style>
+        <p:txBody>
+          <a:bodyPr rtlCol="0" anchor="ctr"/>
+          <a:lstStyle/>
+          <a:p>
+            <a:pPr algn="ctr"/>
+          </a:p>
+        </p:txBody>
+      </p:sp>
+      <p:sp>
+        <p:nvSpPr>
+          <p:cNvPr id="3" name="Rectangle 2"/>
+          <p:cNvSpPr/>
+          <p:nvPr/>
+        </p:nvSpPr>
+        <p:spPr>
+          <a:xfrm>
+            <a:off x="0" y="6547104"/>
+            <a:ext cx="12191695" cy="310896"/>
+          </a:xfrm>
+          <a:prstGeom prst="rect">
+            <a:avLst/>
+          </a:prstGeom>
+          <a:solidFill>
+            <a:srgbClr val="550055"/>
+          </a:solidFill>
+          <a:ln>
+            <a:noFill/>
+          </a:ln>
+          <a:effectLst/>
+        </p:spPr>
+        <p:style>
+          <a:lnRef idx="1">
+            <a:schemeClr val="accent1"/>
+          </a:lnRef>
+          <a:fillRef idx="3">
+            <a:schemeClr val="accent1"/>
+          </a:fillRef>
+          <a:effectRef idx="2">
+            <a:schemeClr val="accent1"/>
+          </a:effectRef>
+          <a:fontRef idx="minor">
+            <a:schemeClr val="lt1"/>
+          </a:fontRef>
+        </p:style>
+        <p:txBody>
+          <a:bodyPr rtlCol="0" anchor="ctr" tIns="25400" lIns="365760"/>
+          <a:lstStyle/>
+          <a:p>
+            <a:pPr algn="ctr"/>
+            <a:r>
+              <a:rPr sz="900">
+                <a:solidFill>
+                  <a:srgbClr val="FFFFFF"/>
+                </a:solidFill>
+              </a:rPr>
+              <a:t>JTC Group · Target AI Architecture · v2.1</a:t>
+            </a:r>
+          </a:p>
+        </p:txBody>
+      </p:sp>
+      <p:sp>
+        <p:nvSpPr>
+          <p:cNvPr id="4" name="TextBox 3"/>
+          <p:cNvSpPr txBox="1"/>
+          <p:nvPr/>
+        </p:nvSpPr>
+        <p:spPr>
+          <a:xfrm>
+            <a:off x="457200" y="310896"/>
+            <a:ext cx="11247120" cy="822960"/>
+          </a:xfrm>
+          <a:prstGeom prst="rect">
+            <a:avLst/>
+          </a:prstGeom>
+          <a:noFill/>
+        </p:spPr>
+        <p:txBody>
+          <a:bodyPr wrap="none">
+            <a:spAutoFit/>
+          </a:bodyPr>
+          <a:lstStyle/>
+          <a:p>
+            <a:r>
+              <a:rPr sz="3000" b="1">
+                <a:solidFill>
+                  <a:srgbClr val="6B1766"/>
+                </a:solidFill>
+              </a:rPr>
+              <a:t>Option 2 — pros &amp; cons</a:t>
+            </a:r>
+          </a:p>
+        </p:txBody>
+      </p:sp>
+      <p:sp>
+        <p:nvSpPr>
+          <p:cNvPr id="5" name="TextBox 4"/>
+          <p:cNvSpPr txBox="1"/>
+          <p:nvPr/>
+        </p:nvSpPr>
+        <p:spPr>
+          <a:xfrm>
+            <a:off x="457200" y="1188720"/>
+            <a:ext cx="11247120" cy="5120640"/>
+          </a:xfrm>
+          <a:prstGeom prst="rect">
+            <a:avLst/>
+          </a:prstGeom>
+          <a:noFill/>
+        </p:spPr>
+        <p:txBody>
+          <a:bodyPr wrap="square">
+            <a:spAutoFit/>
+          </a:bodyPr>
+          <a:lstStyle/>
+          <a:p/>
+        </p:txBody>
+      </p:sp>
+      <p:sp>
+        <p:nvSpPr>
+          <p:cNvPr id="6" name="TextBox 5"/>
+          <p:cNvSpPr txBox="1"/>
+          <p:nvPr/>
+        </p:nvSpPr>
+        <p:spPr>
+          <a:xfrm>
+            <a:off x="457200" y="1280160"/>
+            <a:ext cx="5532120" cy="4937760"/>
+          </a:xfrm>
+          <a:prstGeom prst="rect">
+            <a:avLst/>
+          </a:prstGeom>
+          <a:noFill/>
+        </p:spPr>
+        <p:txBody>
+          <a:bodyPr wrap="square">
+            <a:spAutoFit/>
+          </a:bodyPr>
+          <a:lstStyle/>
+          <a:p>
+            <a:pPr>
+              <a:spcAft>
+                <a:spcPts val="800"/>
+              </a:spcAft>
+            </a:pPr>
+            <a:r>
+              <a:rPr sz="1900" b="1">
+                <a:solidFill>
+                  <a:srgbClr val="1C7C44"/>
+                </a:solidFill>
+              </a:rPr>
+              <a:t>Pros</a:t>
+            </a:r>
+          </a:p>
+          <a:p>
+            <a:pPr>
+              <a:spcAft>
+                <a:spcPts val="700"/>
+              </a:spcAft>
+            </a:pPr>
+            <a:r>
+              <a:rPr sz="1400" b="1">
+                <a:solidFill>
+                  <a:srgbClr val="1C7C44"/>
+                </a:solidFill>
+              </a:rPr>
+              <a:t>✓  </a:t>
+            </a:r>
+            <a:r>
+              <a:rPr sz="1400">
+                <a:solidFill>
+                  <a:srgbClr val="48484F"/>
+                </a:solidFill>
+              </a:rPr>
+              <a:t>Fully managed — least ops; Microsoft runs the agents, RAG and scaling.</a:t>
+            </a:r>
+          </a:p>
+          <a:p>
+            <a:pPr>
+              <a:spcAft>
+                <a:spcPts val="700"/>
+              </a:spcAft>
+            </a:pPr>
+            <a:r>
+              <a:rPr sz="1400" b="1">
+                <a:solidFill>
+                  <a:srgbClr val="1C7C44"/>
+                </a:solidFill>
+              </a:rPr>
+              <a:t>✓  </a:t>
+            </a:r>
+            <a:r>
+              <a:rPr sz="1400">
+                <a:solidFill>
+                  <a:srgbClr val="48484F"/>
+                </a:solidFill>
+              </a:rPr>
+              <a:t>Deep Microsoft integration: Entra, Purview governance, Fabric, Power BI.</a:t>
+            </a:r>
+          </a:p>
+          <a:p>
+            <a:pPr>
+              <a:spcAft>
+                <a:spcPts val="700"/>
+              </a:spcAft>
+            </a:pPr>
+            <a:r>
+              <a:rPr sz="1400" b="1">
+                <a:solidFill>
+                  <a:srgbClr val="1C7C44"/>
+                </a:solidFill>
+              </a:rPr>
+              <a:t>✓  </a:t>
+            </a:r>
+            <a:r>
+              <a:rPr sz="1400">
+                <a:solidFill>
+                  <a:srgbClr val="48484F"/>
+                </a:solidFill>
+              </a:rPr>
+              <a:t>Enterprise SLA &amp; support — strong fit for a Microsoft-shop like JTC.</a:t>
+            </a:r>
+          </a:p>
+          <a:p>
+            <a:pPr>
+              <a:spcAft>
+                <a:spcPts val="700"/>
+              </a:spcAft>
+            </a:pPr>
+            <a:r>
+              <a:rPr sz="1400" b="1">
+                <a:solidFill>
+                  <a:srgbClr val="1C7C44"/>
+                </a:solidFill>
+              </a:rPr>
+              <a:t>✓  </a:t>
+            </a:r>
+            <a:r>
+              <a:rPr sz="1400">
+                <a:solidFill>
+                  <a:srgbClr val="48484F"/>
+                </a:solidFill>
+              </a:rPr>
+              <a:t>Built-in agent orchestration, managed RAG and evaluations out of the box.</a:t>
+            </a:r>
+          </a:p>
+          <a:p>
+            <a:pPr>
+              <a:spcAft>
+                <a:spcPts val="700"/>
+              </a:spcAft>
+            </a:pPr>
+            <a:r>
+              <a:rPr sz="1400" b="1">
+                <a:solidFill>
+                  <a:srgbClr val="1C7C44"/>
+                </a:solidFill>
+              </a:rPr>
+              <a:t>✓  </a:t>
+            </a:r>
+            <a:r>
+              <a:rPr sz="1400">
+                <a:solidFill>
+                  <a:srgbClr val="48484F"/>
+                </a:solidFill>
+              </a:rPr>
+              <a:t>Fabric unifies data + BI for firmwide reporting.</a:t>
+            </a:r>
+          </a:p>
+        </p:txBody>
+      </p:sp>
+      <p:sp>
+        <p:nvSpPr>
+          <p:cNvPr id="7" name="TextBox 6"/>
+          <p:cNvSpPr txBox="1"/>
+          <p:nvPr/>
+        </p:nvSpPr>
+        <p:spPr>
+          <a:xfrm>
+            <a:off x="6263640" y="1280160"/>
+            <a:ext cx="5532120" cy="4937760"/>
+          </a:xfrm>
+          <a:prstGeom prst="rect">
+            <a:avLst/>
+          </a:prstGeom>
+          <a:noFill/>
+        </p:spPr>
+        <p:txBody>
+          <a:bodyPr wrap="square">
+            <a:spAutoFit/>
+          </a:bodyPr>
+          <a:lstStyle/>
+          <a:p>
+            <a:pPr>
+              <a:spcAft>
+                <a:spcPts val="800"/>
+              </a:spcAft>
+            </a:pPr>
+            <a:r>
+              <a:rPr sz="1900" b="1">
+                <a:solidFill>
+                  <a:srgbClr val="B0353A"/>
+                </a:solidFill>
+              </a:rPr>
+              <a:t>Cons</a:t>
+            </a:r>
+          </a:p>
+          <a:p>
+            <a:pPr>
+              <a:spcAft>
+                <a:spcPts val="700"/>
+              </a:spcAft>
+            </a:pPr>
+            <a:r>
+              <a:rPr sz="1400" b="1">
+                <a:solidFill>
+                  <a:srgbClr val="B0353A"/>
+                </a:solidFill>
+              </a:rPr>
+              <a:t>✕  </a:t>
+            </a:r>
+            <a:r>
+              <a:rPr sz="1400">
+                <a:solidFill>
+                  <a:srgbClr val="48484F"/>
+                </a:solidFill>
+              </a:rPr>
+              <a:t>Vendor lock-in — Azure/Foundry/Fabric-specific; low portability.</a:t>
+            </a:r>
+          </a:p>
+          <a:p>
+            <a:pPr>
+              <a:spcAft>
+                <a:spcPts val="700"/>
+              </a:spcAft>
+            </a:pPr>
+            <a:r>
+              <a:rPr sz="1400" b="1">
+                <a:solidFill>
+                  <a:srgbClr val="B0353A"/>
+                </a:solidFill>
+              </a:rPr>
+              <a:t>✕  </a:t>
+            </a:r>
+            <a:r>
+              <a:rPr sz="1400">
+                <a:solidFill>
+                  <a:srgbClr val="48484F"/>
+                </a:solidFill>
+              </a:rPr>
+              <a:t>Rework: migrate off LangGraph/Neo4j to Foundry Agents + Fabric.</a:t>
+            </a:r>
+          </a:p>
+          <a:p>
+            <a:pPr>
+              <a:spcAft>
+                <a:spcPts val="700"/>
+              </a:spcAft>
+            </a:pPr>
+            <a:r>
+              <a:rPr sz="1400" b="1">
+                <a:solidFill>
+                  <a:srgbClr val="B0353A"/>
+                </a:solidFill>
+              </a:rPr>
+              <a:t>✕  </a:t>
+            </a:r>
+            <a:r>
+              <a:rPr sz="1400">
+                <a:solidFill>
+                  <a:srgbClr val="48484F"/>
+                </a:solidFill>
+              </a:rPr>
+              <a:t>Model choice steered to OpenAI; less control over orchestration internals.</a:t>
+            </a:r>
+          </a:p>
+          <a:p>
+            <a:pPr>
+              <a:spcAft>
+                <a:spcPts val="700"/>
+              </a:spcAft>
+            </a:pPr>
+            <a:r>
+              <a:rPr sz="1400" b="1">
+                <a:solidFill>
+                  <a:srgbClr val="B0353A"/>
+                </a:solidFill>
+              </a:rPr>
+              <a:t>✕  </a:t>
+            </a:r>
+            <a:r>
+              <a:rPr sz="1400">
+                <a:solidFill>
+                  <a:srgbClr val="48484F"/>
+                </a:solidFill>
+              </a:rPr>
+              <a:t>Fabric capacity (F-SKUs) + Search + Foundry can be costly &amp; hard to predict.</a:t>
+            </a:r>
+          </a:p>
+          <a:p>
+            <a:pPr>
+              <a:spcAft>
+                <a:spcPts val="700"/>
+              </a:spcAft>
+            </a:pPr>
+            <a:r>
+              <a:rPr sz="1400" b="1">
+                <a:solidFill>
+                  <a:srgbClr val="B0353A"/>
+                </a:solidFill>
+              </a:rPr>
+              <a:t>✕  </a:t>
+            </a:r>
+            <a:r>
+              <a:rPr sz="1400">
+                <a:solidFill>
+                  <a:srgbClr val="48484F"/>
+                </a:solidFill>
+              </a:rPr>
+              <a:t>Managed-agent surface is newer and still maturing.</a:t>
+            </a:r>
+          </a:p>
+        </p:txBody>
+      </p:sp>
+    </p:spTree>
+  </p:cSld>
+  <p:clrMapOvr>
+    <a:masterClrMapping/>
+  </p:clrMapOvr>
+</p:sld>
+</file>
+
+<file path=ppt/slides/slide12.xml><?xml version="1.0" encoding="utf-8"?>
+<p:sld xmlns:a="http://schemas.openxmlformats.org/drawingml/2006/main" xmlns:p="http://schemas.openxmlformats.org/presentationml/2006/main" xmlns:r="http://schemas.openxmlformats.org/officeDocument/2006/relationships">
+  <p:cSld>
+    <p:spTree>
+      <p:nvGrpSpPr>
+        <p:cNvPr id="1" name=""/>
+        <p:cNvGrpSpPr/>
+        <p:nvPr/>
+      </p:nvGrpSpPr>
+      <p:grpSpPr/>
+      <p:sp>
+        <p:nvSpPr>
+          <p:cNvPr id="2" name="Rectangle 1"/>
+          <p:cNvSpPr/>
+          <p:nvPr/>
+        </p:nvSpPr>
+        <p:spPr>
+          <a:xfrm>
+            <a:off x="0" y="0"/>
+            <a:ext cx="12191695" cy="146304"/>
+          </a:xfrm>
+          <a:prstGeom prst="rect">
+            <a:avLst/>
+          </a:prstGeom>
+          <a:solidFill>
+            <a:srgbClr val="550055"/>
+          </a:solidFill>
+          <a:ln>
+            <a:noFill/>
+          </a:ln>
+          <a:effectLst/>
+        </p:spPr>
+        <p:style>
+          <a:lnRef idx="1">
+            <a:schemeClr val="accent1"/>
+          </a:lnRef>
+          <a:fillRef idx="3">
+            <a:schemeClr val="accent1"/>
+          </a:fillRef>
+          <a:effectRef idx="2">
+            <a:schemeClr val="accent1"/>
+          </a:effectRef>
+          <a:fontRef idx="minor">
+            <a:schemeClr val="lt1"/>
+          </a:fontRef>
+        </p:style>
+        <p:txBody>
+          <a:bodyPr rtlCol="0" anchor="ctr"/>
+          <a:lstStyle/>
+          <a:p>
+            <a:pPr algn="ctr"/>
+          </a:p>
+        </p:txBody>
+      </p:sp>
+      <p:sp>
+        <p:nvSpPr>
+          <p:cNvPr id="3" name="Rectangle 2"/>
+          <p:cNvSpPr/>
+          <p:nvPr/>
+        </p:nvSpPr>
+        <p:spPr>
+          <a:xfrm>
+            <a:off x="0" y="6547104"/>
+            <a:ext cx="12191695" cy="310896"/>
+          </a:xfrm>
+          <a:prstGeom prst="rect">
+            <a:avLst/>
+          </a:prstGeom>
+          <a:solidFill>
+            <a:srgbClr val="550055"/>
+          </a:solidFill>
+          <a:ln>
+            <a:noFill/>
+          </a:ln>
+          <a:effectLst/>
+        </p:spPr>
+        <p:style>
+          <a:lnRef idx="1">
+            <a:schemeClr val="accent1"/>
+          </a:lnRef>
+          <a:fillRef idx="3">
+            <a:schemeClr val="accent1"/>
+          </a:fillRef>
+          <a:effectRef idx="2">
+            <a:schemeClr val="accent1"/>
+          </a:effectRef>
+          <a:fontRef idx="minor">
+            <a:schemeClr val="lt1"/>
+          </a:fontRef>
+        </p:style>
+        <p:txBody>
+          <a:bodyPr rtlCol="0" anchor="ctr" tIns="25400" lIns="365760"/>
+          <a:lstStyle/>
+          <a:p>
+            <a:pPr algn="ctr"/>
+            <a:r>
+              <a:rPr sz="900">
+                <a:solidFill>
+                  <a:srgbClr val="FFFFFF"/>
+                </a:solidFill>
+              </a:rPr>
+              <a:t>JTC Group · Target AI Architecture · v2.1</a:t>
             </a:r>
           </a:p>
         </p:txBody>
@@ -4338,7 +5740,7 @@
 </p:sld>
 </file>
 
-<file path=ppt/slides/slide11.xml><?xml version="1.0" encoding="utf-8"?>
+<file path=ppt/slides/slide13.xml><?xml version="1.0" encoding="utf-8"?>
 <p:sld xmlns:a="http://schemas.openxmlformats.org/drawingml/2006/main" xmlns:p="http://schemas.openxmlformats.org/presentationml/2006/main" xmlns:r="http://schemas.openxmlformats.org/officeDocument/2006/relationships">
   <p:cSld>
     <p:spTree>
@@ -4439,7 +5841,951 @@
                   <a:srgbClr val="FFFFFF"/>
                 </a:solidFill>
               </a:rPr>
-              <a:t>JTC Group · Target AI Architecture · v2.0</a:t>
+              <a:t>JTC Group · Target AI Architecture · v2.1</a:t>
+            </a:r>
+          </a:p>
+        </p:txBody>
+      </p:sp>
+      <p:sp>
+        <p:nvSpPr>
+          <p:cNvPr id="4" name="TextBox 3"/>
+          <p:cNvSpPr txBox="1"/>
+          <p:nvPr/>
+        </p:nvSpPr>
+        <p:spPr>
+          <a:xfrm>
+            <a:off x="457200" y="310896"/>
+            <a:ext cx="11247120" cy="822960"/>
+          </a:xfrm>
+          <a:prstGeom prst="rect">
+            <a:avLst/>
+          </a:prstGeom>
+          <a:noFill/>
+        </p:spPr>
+        <p:txBody>
+          <a:bodyPr wrap="none">
+            <a:spAutoFit/>
+          </a:bodyPr>
+          <a:lstStyle/>
+          <a:p>
+            <a:r>
+              <a:rPr sz="3000" b="1">
+                <a:solidFill>
+                  <a:srgbClr val="6B1766"/>
+                </a:solidFill>
+              </a:rPr>
+              <a:t>Indicative cost shape</a:t>
+            </a:r>
+          </a:p>
+        </p:txBody>
+      </p:sp>
+      <p:sp>
+        <p:nvSpPr>
+          <p:cNvPr id="5" name="TextBox 4"/>
+          <p:cNvSpPr txBox="1"/>
+          <p:nvPr/>
+        </p:nvSpPr>
+        <p:spPr>
+          <a:xfrm>
+            <a:off x="457200" y="1188720"/>
+            <a:ext cx="11247120" cy="5120640"/>
+          </a:xfrm>
+          <a:prstGeom prst="rect">
+            <a:avLst/>
+          </a:prstGeom>
+          <a:noFill/>
+        </p:spPr>
+        <p:txBody>
+          <a:bodyPr wrap="square">
+            <a:spAutoFit/>
+          </a:bodyPr>
+          <a:lstStyle/>
+          <a:p>
+            <a:pPr>
+              <a:spcAft>
+                <a:spcPts val="1200"/>
+              </a:spcAft>
+            </a:pPr>
+            <a:r>
+              <a:rPr sz="1500" b="0">
+                <a:solidFill>
+                  <a:srgbClr val="48484F"/>
+                </a:solidFill>
+              </a:rPr>
+              <a:t>Illustrative only — actuals depend on volume, region, capacity reservations and model mix. $ = lower, $$$ = higher.</a:t>
+            </a:r>
+          </a:p>
+        </p:txBody>
+      </p:sp>
+      <p:graphicFrame>
+        <p:nvGraphicFramePr>
+          <p:cNvPr id="6" name="Table 5"/>
+          <p:cNvGraphicFramePr>
+            <a:graphicFrameLocks noGrp="1"/>
+          </p:cNvGraphicFramePr>
+          <p:nvPr/>
+        </p:nvGraphicFramePr>
+        <p:xfrm>
+          <a:off x="457200" y="1234440"/>
+          <a:ext cx="11247120" cy="4937760"/>
+        </p:xfrm>
+        <a:graphic>
+          <a:graphicData uri="http://schemas.openxmlformats.org/drawingml/2006/table">
+            <a:tbl>
+              <a:tblPr firstRow="1" bandRow="1">
+                <a:tableStyleId>{5C22544A-7EE6-4342-B048-85BDC9FD1C3A}</a:tableStyleId>
+              </a:tblPr>
+              <a:tblGrid>
+                <a:gridCol w="2286000"/>
+                <a:gridCol w="4663440"/>
+                <a:gridCol w="4297680"/>
+              </a:tblGrid>
+              <a:tr h="705394">
+                <a:tc>
+                  <a:txBody>
+                    <a:bodyPr/>
+                    <a:lstStyle/>
+                    <a:p>
+                      <a:r>
+                        <a:rPr sz="1300" b="1">
+                          <a:solidFill>
+                            <a:srgbClr val="FFFFFF"/>
+                          </a:solidFill>
+                        </a:rPr>
+                        <a:t>Area</a:t>
+                      </a:r>
+                    </a:p>
+                  </a:txBody>
+                  <a:tcPr>
+                    <a:solidFill>
+                      <a:srgbClr val="550055"/>
+                    </a:solidFill>
+                  </a:tcPr>
+                </a:tc>
+                <a:tc>
+                  <a:txBody>
+                    <a:bodyPr/>
+                    <a:lstStyle/>
+                    <a:p>
+                      <a:r>
+                        <a:rPr sz="1300" b="1">
+                          <a:solidFill>
+                            <a:srgbClr val="FFFFFF"/>
+                          </a:solidFill>
+                        </a:rPr>
+                        <a:t>Option 1 · Open-source</a:t>
+                      </a:r>
+                    </a:p>
+                  </a:txBody>
+                  <a:tcPr>
+                    <a:solidFill>
+                      <a:srgbClr val="550055"/>
+                    </a:solidFill>
+                  </a:tcPr>
+                </a:tc>
+                <a:tc>
+                  <a:txBody>
+                    <a:bodyPr/>
+                    <a:lstStyle/>
+                    <a:p>
+                      <a:r>
+                        <a:rPr sz="1300" b="1">
+                          <a:solidFill>
+                            <a:srgbClr val="FFFFFF"/>
+                          </a:solidFill>
+                        </a:rPr>
+                        <a:t>Option 2 · MS-managed</a:t>
+                      </a:r>
+                    </a:p>
+                  </a:txBody>
+                  <a:tcPr>
+                    <a:solidFill>
+                      <a:srgbClr val="550055"/>
+                    </a:solidFill>
+                  </a:tcPr>
+                </a:tc>
+              </a:tr>
+              <a:tr h="705394">
+                <a:tc>
+                  <a:txBody>
+                    <a:bodyPr/>
+                    <a:lstStyle/>
+                    <a:p>
+                      <a:r>
+                        <a:rPr sz="1150" b="1">
+                          <a:solidFill>
+                            <a:srgbClr val="6B1766"/>
+                          </a:solidFill>
+                        </a:rPr>
+                        <a:t>Compute</a:t>
+                      </a:r>
+                    </a:p>
+                  </a:txBody>
+                  <a:tcPr>
+                    <a:solidFill>
+                      <a:srgbClr val="F7F4F9"/>
+                    </a:solidFill>
+                  </a:tcPr>
+                </a:tc>
+                <a:tc>
+                  <a:txBody>
+                    <a:bodyPr/>
+                    <a:lstStyle/>
+                    <a:p>
+                      <a:r>
+                        <a:rPr sz="1150" b="0">
+                          <a:solidFill>
+                            <a:srgbClr val="48484F"/>
+                          </a:solidFill>
+                        </a:rPr>
+                        <a:t>Container Apps — $ (consumption)</a:t>
+                      </a:r>
+                    </a:p>
+                  </a:txBody>
+                  <a:tcPr>
+                    <a:solidFill>
+                      <a:srgbClr val="F7F4F9"/>
+                    </a:solidFill>
+                  </a:tcPr>
+                </a:tc>
+                <a:tc>
+                  <a:txBody>
+                    <a:bodyPr/>
+                    <a:lstStyle/>
+                    <a:p>
+                      <a:r>
+                        <a:rPr sz="1150" b="0">
+                          <a:solidFill>
+                            <a:srgbClr val="48484F"/>
+                          </a:solidFill>
+                        </a:rPr>
+                        <a:t>Foundry Agent Service — $$ (managed)</a:t>
+                      </a:r>
+                    </a:p>
+                  </a:txBody>
+                  <a:tcPr>
+                    <a:solidFill>
+                      <a:srgbClr val="F7F4F9"/>
+                    </a:solidFill>
+                  </a:tcPr>
+                </a:tc>
+              </a:tr>
+              <a:tr h="705394">
+                <a:tc>
+                  <a:txBody>
+                    <a:bodyPr/>
+                    <a:lstStyle/>
+                    <a:p>
+                      <a:r>
+                        <a:rPr sz="1150" b="1">
+                          <a:solidFill>
+                            <a:srgbClr val="6B1766"/>
+                          </a:solidFill>
+                        </a:rPr>
+                        <a:t>Data</a:t>
+                      </a:r>
+                    </a:p>
+                  </a:txBody>
+                  <a:tcPr>
+                    <a:solidFill>
+                      <a:srgbClr val="FFFFFF"/>
+                    </a:solidFill>
+                  </a:tcPr>
+                </a:tc>
+                <a:tc>
+                  <a:txBody>
+                    <a:bodyPr/>
+                    <a:lstStyle/>
+                    <a:p>
+                      <a:r>
+                        <a:rPr sz="1150" b="0">
+                          <a:solidFill>
+                            <a:srgbClr val="48484F"/>
+                          </a:solidFill>
+                        </a:rPr>
+                        <a:t>PostgreSQL Flexible + Blob — $</a:t>
+                      </a:r>
+                    </a:p>
+                  </a:txBody>
+                  <a:tcPr>
+                    <a:solidFill>
+                      <a:srgbClr val="FFFFFF"/>
+                    </a:solidFill>
+                  </a:tcPr>
+                </a:tc>
+                <a:tc>
+                  <a:txBody>
+                    <a:bodyPr/>
+                    <a:lstStyle/>
+                    <a:p>
+                      <a:r>
+                        <a:rPr sz="1150" b="0">
+                          <a:solidFill>
+                            <a:srgbClr val="48484F"/>
+                          </a:solidFill>
+                        </a:rPr>
+                        <a:t>Microsoft Fabric capacity (F-SKU) — $$$</a:t>
+                      </a:r>
+                    </a:p>
+                  </a:txBody>
+                  <a:tcPr>
+                    <a:solidFill>
+                      <a:srgbClr val="FFFFFF"/>
+                    </a:solidFill>
+                  </a:tcPr>
+                </a:tc>
+              </a:tr>
+              <a:tr h="705394">
+                <a:tc>
+                  <a:txBody>
+                    <a:bodyPr/>
+                    <a:lstStyle/>
+                    <a:p>
+                      <a:r>
+                        <a:rPr sz="1150" b="1">
+                          <a:solidFill>
+                            <a:srgbClr val="6B1766"/>
+                          </a:solidFill>
+                        </a:rPr>
+                        <a:t>Search / RAG</a:t>
+                      </a:r>
+                    </a:p>
+                  </a:txBody>
+                  <a:tcPr>
+                    <a:solidFill>
+                      <a:srgbClr val="F7F4F9"/>
+                    </a:solidFill>
+                  </a:tcPr>
+                </a:tc>
+                <a:tc>
+                  <a:txBody>
+                    <a:bodyPr/>
+                    <a:lstStyle/>
+                    <a:p>
+                      <a:r>
+                        <a:rPr sz="1150" b="0">
+                          <a:solidFill>
+                            <a:srgbClr val="48484F"/>
+                          </a:solidFill>
+                        </a:rPr>
+                        <a:t>pgvector in Postgres — included</a:t>
+                      </a:r>
+                    </a:p>
+                  </a:txBody>
+                  <a:tcPr>
+                    <a:solidFill>
+                      <a:srgbClr val="F7F4F9"/>
+                    </a:solidFill>
+                  </a:tcPr>
+                </a:tc>
+                <a:tc>
+                  <a:txBody>
+                    <a:bodyPr/>
+                    <a:lstStyle/>
+                    <a:p>
+                      <a:r>
+                        <a:rPr sz="1150" b="0">
+                          <a:solidFill>
+                            <a:srgbClr val="48484F"/>
+                          </a:solidFill>
+                        </a:rPr>
+                        <a:t>Azure AI Search — $$</a:t>
+                      </a:r>
+                    </a:p>
+                  </a:txBody>
+                  <a:tcPr>
+                    <a:solidFill>
+                      <a:srgbClr val="F7F4F9"/>
+                    </a:solidFill>
+                  </a:tcPr>
+                </a:tc>
+              </a:tr>
+              <a:tr h="705394">
+                <a:tc>
+                  <a:txBody>
+                    <a:bodyPr/>
+                    <a:lstStyle/>
+                    <a:p>
+                      <a:r>
+                        <a:rPr sz="1150" b="1">
+                          <a:solidFill>
+                            <a:srgbClr val="6B1766"/>
+                          </a:solidFill>
+                        </a:rPr>
+                        <a:t>LLM</a:t>
+                      </a:r>
+                    </a:p>
+                  </a:txBody>
+                  <a:tcPr>
+                    <a:solidFill>
+                      <a:srgbClr val="FFFFFF"/>
+                    </a:solidFill>
+                  </a:tcPr>
+                </a:tc>
+                <a:tc>
+                  <a:txBody>
+                    <a:bodyPr/>
+                    <a:lstStyle/>
+                    <a:p>
+                      <a:r>
+                        <a:rPr sz="1150" b="0">
+                          <a:solidFill>
+                            <a:srgbClr val="48484F"/>
+                          </a:solidFill>
+                        </a:rPr>
+                        <a:t>Foundry usage (Claude / others) — $$</a:t>
+                      </a:r>
+                    </a:p>
+                  </a:txBody>
+                  <a:tcPr>
+                    <a:solidFill>
+                      <a:srgbClr val="FFFFFF"/>
+                    </a:solidFill>
+                  </a:tcPr>
+                </a:tc>
+                <a:tc>
+                  <a:txBody>
+                    <a:bodyPr/>
+                    <a:lstStyle/>
+                    <a:p>
+                      <a:r>
+                        <a:rPr sz="1150" b="0">
+                          <a:solidFill>
+                            <a:srgbClr val="48484F"/>
+                          </a:solidFill>
+                        </a:rPr>
+                        <a:t>Azure OpenAI usage — $$</a:t>
+                      </a:r>
+                    </a:p>
+                  </a:txBody>
+                  <a:tcPr>
+                    <a:solidFill>
+                      <a:srgbClr val="FFFFFF"/>
+                    </a:solidFill>
+                  </a:tcPr>
+                </a:tc>
+              </a:tr>
+              <a:tr h="705394">
+                <a:tc>
+                  <a:txBody>
+                    <a:bodyPr/>
+                    <a:lstStyle/>
+                    <a:p>
+                      <a:r>
+                        <a:rPr sz="1150" b="1">
+                          <a:solidFill>
+                            <a:srgbClr val="6B1766"/>
+                          </a:solidFill>
+                        </a:rPr>
+                        <a:t>Observability</a:t>
+                      </a:r>
+                    </a:p>
+                  </a:txBody>
+                  <a:tcPr>
+                    <a:solidFill>
+                      <a:srgbClr val="F7F4F9"/>
+                    </a:solidFill>
+                  </a:tcPr>
+                </a:tc>
+                <a:tc>
+                  <a:txBody>
+                    <a:bodyPr/>
+                    <a:lstStyle/>
+                    <a:p>
+                      <a:r>
+                        <a:rPr sz="1150" b="0">
+                          <a:solidFill>
+                            <a:srgbClr val="48484F"/>
+                          </a:solidFill>
+                        </a:rPr>
+                        <a:t>Langfuse self-hosted — $</a:t>
+                      </a:r>
+                    </a:p>
+                  </a:txBody>
+                  <a:tcPr>
+                    <a:solidFill>
+                      <a:srgbClr val="F7F4F9"/>
+                    </a:solidFill>
+                  </a:tcPr>
+                </a:tc>
+                <a:tc>
+                  <a:txBody>
+                    <a:bodyPr/>
+                    <a:lstStyle/>
+                    <a:p>
+                      <a:r>
+                        <a:rPr sz="1150" b="0">
+                          <a:solidFill>
+                            <a:srgbClr val="48484F"/>
+                          </a:solidFill>
+                        </a:rPr>
+                        <a:t>Azure Monitor — $</a:t>
+                      </a:r>
+                    </a:p>
+                  </a:txBody>
+                  <a:tcPr>
+                    <a:solidFill>
+                      <a:srgbClr val="F7F4F9"/>
+                    </a:solidFill>
+                  </a:tcPr>
+                </a:tc>
+              </a:tr>
+              <a:tr h="705396">
+                <a:tc>
+                  <a:txBody>
+                    <a:bodyPr/>
+                    <a:lstStyle/>
+                    <a:p>
+                      <a:r>
+                        <a:rPr sz="1150" b="1">
+                          <a:solidFill>
+                            <a:srgbClr val="6B1766"/>
+                          </a:solidFill>
+                        </a:rPr>
+                        <a:t>Cost shape</a:t>
+                      </a:r>
+                    </a:p>
+                  </a:txBody>
+                  <a:tcPr>
+                    <a:solidFill>
+                      <a:srgbClr val="FFFFFF"/>
+                    </a:solidFill>
+                  </a:tcPr>
+                </a:tc>
+                <a:tc>
+                  <a:txBody>
+                    <a:bodyPr/>
+                    <a:lstStyle/>
+                    <a:p>
+                      <a:r>
+                        <a:rPr sz="1150" b="0">
+                          <a:solidFill>
+                            <a:srgbClr val="48484F"/>
+                          </a:solidFill>
+                        </a:rPr>
+                        <a:t>Lower fixed · usage-based · portable</a:t>
+                      </a:r>
+                    </a:p>
+                  </a:txBody>
+                  <a:tcPr>
+                    <a:solidFill>
+                      <a:srgbClr val="FFFFFF"/>
+                    </a:solidFill>
+                  </a:tcPr>
+                </a:tc>
+                <a:tc>
+                  <a:txBody>
+                    <a:bodyPr/>
+                    <a:lstStyle/>
+                    <a:p>
+                      <a:r>
+                        <a:rPr sz="1150" b="0">
+                          <a:solidFill>
+                            <a:srgbClr val="48484F"/>
+                          </a:solidFill>
+                        </a:rPr>
+                        <a:t>Higher fixed (Fabric) · managed</a:t>
+                      </a:r>
+                    </a:p>
+                  </a:txBody>
+                  <a:tcPr>
+                    <a:solidFill>
+                      <a:srgbClr val="FFFFFF"/>
+                    </a:solidFill>
+                  </a:tcPr>
+                </a:tc>
+              </a:tr>
+            </a:tbl>
+          </a:graphicData>
+        </a:graphic>
+      </p:graphicFrame>
+    </p:spTree>
+  </p:cSld>
+  <p:clrMapOvr>
+    <a:masterClrMapping/>
+  </p:clrMapOvr>
+</p:sld>
+</file>
+
+<file path=ppt/slides/slide14.xml><?xml version="1.0" encoding="utf-8"?>
+<p:sld xmlns:a="http://schemas.openxmlformats.org/drawingml/2006/main" xmlns:p="http://schemas.openxmlformats.org/presentationml/2006/main" xmlns:r="http://schemas.openxmlformats.org/officeDocument/2006/relationships">
+  <p:cSld>
+    <p:spTree>
+      <p:nvGrpSpPr>
+        <p:cNvPr id="1" name=""/>
+        <p:cNvGrpSpPr/>
+        <p:nvPr/>
+      </p:nvGrpSpPr>
+      <p:grpSpPr/>
+      <p:sp>
+        <p:nvSpPr>
+          <p:cNvPr id="2" name="Rectangle 1"/>
+          <p:cNvSpPr/>
+          <p:nvPr/>
+        </p:nvSpPr>
+        <p:spPr>
+          <a:xfrm>
+            <a:off x="0" y="0"/>
+            <a:ext cx="12191695" cy="146304"/>
+          </a:xfrm>
+          <a:prstGeom prst="rect">
+            <a:avLst/>
+          </a:prstGeom>
+          <a:solidFill>
+            <a:srgbClr val="550055"/>
+          </a:solidFill>
+          <a:ln>
+            <a:noFill/>
+          </a:ln>
+          <a:effectLst/>
+        </p:spPr>
+        <p:style>
+          <a:lnRef idx="1">
+            <a:schemeClr val="accent1"/>
+          </a:lnRef>
+          <a:fillRef idx="3">
+            <a:schemeClr val="accent1"/>
+          </a:fillRef>
+          <a:effectRef idx="2">
+            <a:schemeClr val="accent1"/>
+          </a:effectRef>
+          <a:fontRef idx="minor">
+            <a:schemeClr val="lt1"/>
+          </a:fontRef>
+        </p:style>
+        <p:txBody>
+          <a:bodyPr rtlCol="0" anchor="ctr"/>
+          <a:lstStyle/>
+          <a:p>
+            <a:pPr algn="ctr"/>
+          </a:p>
+        </p:txBody>
+      </p:sp>
+      <p:sp>
+        <p:nvSpPr>
+          <p:cNvPr id="3" name="Rectangle 2"/>
+          <p:cNvSpPr/>
+          <p:nvPr/>
+        </p:nvSpPr>
+        <p:spPr>
+          <a:xfrm>
+            <a:off x="0" y="6547104"/>
+            <a:ext cx="12191695" cy="310896"/>
+          </a:xfrm>
+          <a:prstGeom prst="rect">
+            <a:avLst/>
+          </a:prstGeom>
+          <a:solidFill>
+            <a:srgbClr val="550055"/>
+          </a:solidFill>
+          <a:ln>
+            <a:noFill/>
+          </a:ln>
+          <a:effectLst/>
+        </p:spPr>
+        <p:style>
+          <a:lnRef idx="1">
+            <a:schemeClr val="accent1"/>
+          </a:lnRef>
+          <a:fillRef idx="3">
+            <a:schemeClr val="accent1"/>
+          </a:fillRef>
+          <a:effectRef idx="2">
+            <a:schemeClr val="accent1"/>
+          </a:effectRef>
+          <a:fontRef idx="minor">
+            <a:schemeClr val="lt1"/>
+          </a:fontRef>
+        </p:style>
+        <p:txBody>
+          <a:bodyPr rtlCol="0" anchor="ctr" tIns="25400" lIns="365760"/>
+          <a:lstStyle/>
+          <a:p>
+            <a:pPr algn="ctr"/>
+            <a:r>
+              <a:rPr sz="900">
+                <a:solidFill>
+                  <a:srgbClr val="FFFFFF"/>
+                </a:solidFill>
+              </a:rPr>
+              <a:t>JTC Group · Target AI Architecture · v2.1</a:t>
+            </a:r>
+          </a:p>
+        </p:txBody>
+      </p:sp>
+      <p:sp>
+        <p:nvSpPr>
+          <p:cNvPr id="4" name="TextBox 3"/>
+          <p:cNvSpPr txBox="1"/>
+          <p:nvPr/>
+        </p:nvSpPr>
+        <p:spPr>
+          <a:xfrm>
+            <a:off x="457200" y="310896"/>
+            <a:ext cx="11247120" cy="822960"/>
+          </a:xfrm>
+          <a:prstGeom prst="rect">
+            <a:avLst/>
+          </a:prstGeom>
+          <a:noFill/>
+        </p:spPr>
+        <p:txBody>
+          <a:bodyPr wrap="none">
+            <a:spAutoFit/>
+          </a:bodyPr>
+          <a:lstStyle/>
+          <a:p>
+            <a:r>
+              <a:rPr sz="3000" b="1">
+                <a:solidFill>
+                  <a:srgbClr val="6B1766"/>
+                </a:solidFill>
+              </a:rPr>
+              <a:t>Phased rollout</a:t>
+            </a:r>
+          </a:p>
+        </p:txBody>
+      </p:sp>
+      <p:sp>
+        <p:nvSpPr>
+          <p:cNvPr id="5" name="TextBox 4"/>
+          <p:cNvSpPr txBox="1"/>
+          <p:nvPr/>
+        </p:nvSpPr>
+        <p:spPr>
+          <a:xfrm>
+            <a:off x="457200" y="1188720"/>
+            <a:ext cx="11247120" cy="5120640"/>
+          </a:xfrm>
+          <a:prstGeom prst="rect">
+            <a:avLst/>
+          </a:prstGeom>
+          <a:noFill/>
+        </p:spPr>
+        <p:txBody>
+          <a:bodyPr wrap="square">
+            <a:spAutoFit/>
+          </a:bodyPr>
+          <a:lstStyle/>
+          <a:p>
+            <a:pPr>
+              <a:spcAft>
+                <a:spcPts val="1200"/>
+              </a:spcAft>
+            </a:pPr>
+            <a:r>
+              <a:rPr sz="1500" b="0">
+                <a:solidFill>
+                  <a:srgbClr val="48484F"/>
+                </a:solidFill>
+              </a:rPr>
+              <a:t>A low-risk path: land the portable stack first, layer in skills + MCP, and adopt managed services only if firmwide BI / ops demand it.</a:t>
+            </a:r>
+          </a:p>
+          <a:p>
+            <a:pPr>
+              <a:spcAft>
+                <a:spcPts val="700"/>
+              </a:spcAft>
+            </a:pPr>
+            <a:r>
+              <a:rPr sz="1500" b="1">
+                <a:solidFill>
+                  <a:srgbClr val="550055"/>
+                </a:solidFill>
+              </a:rPr>
+              <a:t>Phase 1 · 0–4 weeks  —  </a:t>
+            </a:r>
+            <a:r>
+              <a:rPr sz="1400">
+                <a:solidFill>
+                  <a:srgbClr val="48484F"/>
+                </a:solidFill>
+              </a:rPr>
+              <a:t>Land Option 1 on Azure — Container Apps + PostgreSQL + Blob + Azure AI Foundry (Claude default) + Langfuse; migrate the current app; the tax skill pack goes live</a:t>
+            </a:r>
+          </a:p>
+          <a:p>
+            <a:pPr>
+              <a:spcAft>
+                <a:spcPts val="700"/>
+              </a:spcAft>
+            </a:pPr>
+            <a:r>
+              <a:rPr sz="1500" b="1">
+                <a:solidFill>
+                  <a:srgbClr val="550055"/>
+                </a:solidFill>
+              </a:rPr>
+              <a:t>Phase 2 · 1–2 months  —  </a:t>
+            </a:r>
+            <a:r>
+              <a:rPr sz="1400">
+                <a:solidFill>
+                  <a:srgbClr val="48484F"/>
+                </a:solidFill>
+              </a:rPr>
+              <a:t>Stand up MCP servers (portfolio, docs, CRM, office) and the single-family-office lead + project-management skill packs; per-team rollout</a:t>
+            </a:r>
+          </a:p>
+          <a:p>
+            <a:pPr>
+              <a:spcAft>
+                <a:spcPts val="700"/>
+              </a:spcAft>
+            </a:pPr>
+            <a:r>
+              <a:rPr sz="1500" b="1">
+                <a:solidFill>
+                  <a:srgbClr val="550055"/>
+                </a:solidFill>
+              </a:rPr>
+              <a:t>Phase 3 · 2–4 months  —  </a:t>
+            </a:r>
+            <a:r>
+              <a:rPr sz="1400">
+                <a:solidFill>
+                  <a:srgbClr val="48484F"/>
+                </a:solidFill>
+              </a:rPr>
+              <a:t>Harden — quality / eval loop, SSO, governance; optional Microsoft Fabric / Power BI for firmwide BI</a:t>
+            </a:r>
+          </a:p>
+          <a:p>
+            <a:pPr>
+              <a:spcAft>
+                <a:spcPts val="700"/>
+              </a:spcAft>
+            </a:pPr>
+            <a:r>
+              <a:rPr sz="1500" b="1">
+                <a:solidFill>
+                  <a:srgbClr val="550055"/>
+                </a:solidFill>
+              </a:rPr>
+              <a:t>Phase 4 · optional  —  </a:t>
+            </a:r>
+            <a:r>
+              <a:rPr sz="1400">
+                <a:solidFill>
+                  <a:srgbClr val="48484F"/>
+                </a:solidFill>
+              </a:rPr>
+              <a:t>Evaluate the managed Option 2 path for enterprise scale — skills + MCP carry over, so it is incremental, not a rebuild</a:t>
+            </a:r>
+          </a:p>
+        </p:txBody>
+      </p:sp>
+    </p:spTree>
+  </p:cSld>
+  <p:clrMapOvr>
+    <a:masterClrMapping/>
+  </p:clrMapOvr>
+</p:sld>
+</file>
+
+<file path=ppt/slides/slide15.xml><?xml version="1.0" encoding="utf-8"?>
+<p:sld xmlns:a="http://schemas.openxmlformats.org/drawingml/2006/main" xmlns:p="http://schemas.openxmlformats.org/presentationml/2006/main" xmlns:r="http://schemas.openxmlformats.org/officeDocument/2006/relationships">
+  <p:cSld>
+    <p:spTree>
+      <p:nvGrpSpPr>
+        <p:cNvPr id="1" name=""/>
+        <p:cNvGrpSpPr/>
+        <p:nvPr/>
+      </p:nvGrpSpPr>
+      <p:grpSpPr/>
+      <p:sp>
+        <p:nvSpPr>
+          <p:cNvPr id="2" name="Rectangle 1"/>
+          <p:cNvSpPr/>
+          <p:nvPr/>
+        </p:nvSpPr>
+        <p:spPr>
+          <a:xfrm>
+            <a:off x="0" y="0"/>
+            <a:ext cx="12191695" cy="146304"/>
+          </a:xfrm>
+          <a:prstGeom prst="rect">
+            <a:avLst/>
+          </a:prstGeom>
+          <a:solidFill>
+            <a:srgbClr val="550055"/>
+          </a:solidFill>
+          <a:ln>
+            <a:noFill/>
+          </a:ln>
+          <a:effectLst/>
+        </p:spPr>
+        <p:style>
+          <a:lnRef idx="1">
+            <a:schemeClr val="accent1"/>
+          </a:lnRef>
+          <a:fillRef idx="3">
+            <a:schemeClr val="accent1"/>
+          </a:fillRef>
+          <a:effectRef idx="2">
+            <a:schemeClr val="accent1"/>
+          </a:effectRef>
+          <a:fontRef idx="minor">
+            <a:schemeClr val="lt1"/>
+          </a:fontRef>
+        </p:style>
+        <p:txBody>
+          <a:bodyPr rtlCol="0" anchor="ctr"/>
+          <a:lstStyle/>
+          <a:p>
+            <a:pPr algn="ctr"/>
+          </a:p>
+        </p:txBody>
+      </p:sp>
+      <p:sp>
+        <p:nvSpPr>
+          <p:cNvPr id="3" name="Rectangle 2"/>
+          <p:cNvSpPr/>
+          <p:nvPr/>
+        </p:nvSpPr>
+        <p:spPr>
+          <a:xfrm>
+            <a:off x="0" y="6547104"/>
+            <a:ext cx="12191695" cy="310896"/>
+          </a:xfrm>
+          <a:prstGeom prst="rect">
+            <a:avLst/>
+          </a:prstGeom>
+          <a:solidFill>
+            <a:srgbClr val="550055"/>
+          </a:solidFill>
+          <a:ln>
+            <a:noFill/>
+          </a:ln>
+          <a:effectLst/>
+        </p:spPr>
+        <p:style>
+          <a:lnRef idx="1">
+            <a:schemeClr val="accent1"/>
+          </a:lnRef>
+          <a:fillRef idx="3">
+            <a:schemeClr val="accent1"/>
+          </a:fillRef>
+          <a:effectRef idx="2">
+            <a:schemeClr val="accent1"/>
+          </a:effectRef>
+          <a:fontRef idx="minor">
+            <a:schemeClr val="lt1"/>
+          </a:fontRef>
+        </p:style>
+        <p:txBody>
+          <a:bodyPr rtlCol="0" anchor="ctr" tIns="25400" lIns="365760"/>
+          <a:lstStyle/>
+          <a:p>
+            <a:pPr algn="ctr"/>
+            <a:r>
+              <a:rPr sz="900">
+                <a:solidFill>
+                  <a:srgbClr val="FFFFFF"/>
+                </a:solidFill>
+              </a:rPr>
+              <a:t>JTC Group · Target AI Architecture · v2.1</a:t>
             </a:r>
           </a:p>
         </p:txBody>
@@ -4701,7 +7047,7 @@
                   <a:srgbClr val="FFFFFF"/>
                 </a:solidFill>
               </a:rPr>
-              <a:t>JTC Group · Target AI Architecture · v2.0</a:t>
+              <a:t>JTC Group · Target AI Architecture · v2.1</a:t>
             </a:r>
           </a:p>
         </p:txBody>
@@ -5001,7 +7347,7 @@
                   <a:srgbClr val="FFFFFF"/>
                 </a:solidFill>
               </a:rPr>
-              <a:t>JTC Group · Target AI Architecture · v2.0</a:t>
+              <a:t>JTC Group · Target AI Architecture · v2.1</a:t>
             </a:r>
           </a:p>
         </p:txBody>
@@ -5278,7 +7624,7 @@
                   <a:srgbClr val="FFFFFF"/>
                 </a:solidFill>
               </a:rPr>
-              <a:t>JTC Group · Target AI Architecture · v2.0</a:t>
+              <a:t>JTC Group · Target AI Architecture · v2.1</a:t>
             </a:r>
           </a:p>
         </p:txBody>
@@ -5601,7 +7947,7 @@
                   <a:srgbClr val="FFFFFF"/>
                 </a:solidFill>
               </a:rPr>
-              <a:t>JTC Group · Target AI Architecture · v2.0</a:t>
+              <a:t>JTC Group · Target AI Architecture · v2.1</a:t>
             </a:r>
           </a:p>
         </p:txBody>
@@ -5978,7 +8324,7 @@
                   <a:srgbClr val="FFFFFF"/>
                 </a:solidFill>
               </a:rPr>
-              <a:t>JTC Group · Target AI Architecture · v2.0</a:t>
+              <a:t>JTC Group · Target AI Architecture · v2.1</a:t>
             </a:r>
           </a:p>
         </p:txBody>
@@ -6011,7 +8357,15 @@
                   <a:srgbClr val="6B1766"/>
                 </a:solidFill>
               </a:rPr>
-              <a:t>Option 1 — how it flows</a:t>
+              <a:t>Option 1 — architecture at a glance</a:t>
+            </a:r>
+            <a:r>
+              <a:rPr sz="1300" b="1">
+                <a:solidFill>
+                  <a:srgbClr val="BA2A84"/>
+                </a:solidFill>
+              </a:rPr>
+              <a:t>   OPEN-SOURCE</a:t>
             </a:r>
           </a:p>
         </p:txBody>
@@ -6037,119 +8391,747 @@
             <a:spAutoFit/>
           </a:bodyPr>
           <a:lstStyle/>
-          <a:p>
-            <a:pPr>
-              <a:spcAft>
-                <a:spcPts val="900"/>
-              </a:spcAft>
-            </a:pPr>
-            <a:r>
-              <a:rPr sz="1600">
-                <a:solidFill>
-                  <a:srgbClr val="BA2A84"/>
-                </a:solidFill>
-              </a:rPr>
-              <a:t>•  </a:t>
-            </a:r>
-            <a:r>
-              <a:rPr sz="1600" b="0">
+          <a:p/>
+        </p:txBody>
+      </p:sp>
+      <p:sp>
+        <p:nvSpPr>
+          <p:cNvPr id="6" name="Rounded Rectangle 5"/>
+          <p:cNvSpPr/>
+          <p:nvPr/>
+        </p:nvSpPr>
+        <p:spPr>
+          <a:xfrm>
+            <a:off x="457200" y="1371600"/>
+            <a:ext cx="3063240" cy="566928"/>
+          </a:xfrm>
+          <a:prstGeom prst="roundRect">
+            <a:avLst/>
+          </a:prstGeom>
+          <a:solidFill>
+            <a:srgbClr val="550055"/>
+          </a:solidFill>
+          <a:ln>
+            <a:noFill/>
+          </a:ln>
+          <a:effectLst/>
+        </p:spPr>
+        <p:style>
+          <a:lnRef idx="1">
+            <a:schemeClr val="accent1"/>
+          </a:lnRef>
+          <a:fillRef idx="3">
+            <a:schemeClr val="accent1"/>
+          </a:fillRef>
+          <a:effectRef idx="2">
+            <a:schemeClr val="accent1"/>
+          </a:effectRef>
+          <a:fontRef idx="minor">
+            <a:schemeClr val="lt1"/>
+          </a:fontRef>
+        </p:style>
+        <p:txBody>
+          <a:bodyPr rtlCol="0" anchor="ctr" wrap="square" lIns="128016"/>
+          <a:lstStyle/>
+          <a:p>
+            <a:pPr algn="ctr"/>
+            <a:r>
+              <a:rPr sz="1300" b="1">
+                <a:solidFill>
+                  <a:srgbClr val="FFFFFF"/>
+                </a:solidFill>
+              </a:rPr>
+              <a:t>Users</a:t>
+            </a:r>
+          </a:p>
+        </p:txBody>
+      </p:sp>
+      <p:sp>
+        <p:nvSpPr>
+          <p:cNvPr id="7" name="Rounded Rectangle 6"/>
+          <p:cNvSpPr/>
+          <p:nvPr/>
+        </p:nvSpPr>
+        <p:spPr>
+          <a:xfrm>
+            <a:off x="3639312" y="1371600"/>
+            <a:ext cx="8092440" cy="566928"/>
+          </a:xfrm>
+          <a:prstGeom prst="roundRect">
+            <a:avLst/>
+          </a:prstGeom>
+          <a:solidFill>
+            <a:srgbClr val="F4EFF7"/>
+          </a:solidFill>
+          <a:ln w="6350">
+            <a:solidFill>
+              <a:srgbClr val="E6E3EC"/>
+            </a:solidFill>
+          </a:ln>
+          <a:effectLst/>
+        </p:spPr>
+        <p:style>
+          <a:lnRef idx="1">
+            <a:schemeClr val="accent1"/>
+          </a:lnRef>
+          <a:fillRef idx="3">
+            <a:schemeClr val="accent1"/>
+          </a:fillRef>
+          <a:effectRef idx="2">
+            <a:schemeClr val="accent1"/>
+          </a:effectRef>
+          <a:fontRef idx="minor">
+            <a:schemeClr val="lt1"/>
+          </a:fontRef>
+        </p:style>
+        <p:txBody>
+          <a:bodyPr rtlCol="0" anchor="ctr" wrap="square" lIns="146304"/>
+          <a:lstStyle/>
+          <a:p>
+            <a:pPr algn="ctr"/>
+            <a:r>
+              <a:rPr sz="1250">
                 <a:solidFill>
                   <a:srgbClr val="48484F"/>
                 </a:solidFill>
               </a:rPr>
-              <a:t>User → Container Apps (FastHTML) over HTTPS with Entra SSO.</a:t>
-            </a:r>
-          </a:p>
-          <a:p>
-            <a:pPr>
-              <a:spcAft>
-                <a:spcPts val="900"/>
-              </a:spcAft>
-            </a:pPr>
-            <a:r>
-              <a:rPr sz="1600">
-                <a:solidFill>
-                  <a:srgbClr val="BA2A84"/>
-                </a:solidFill>
-              </a:rPr>
-              <a:t>•  </a:t>
-            </a:r>
-            <a:r>
-              <a:rPr sz="1600" b="0">
+              <a:t>Back-office &amp; advisors · Entra ID SSO</a:t>
+            </a:r>
+          </a:p>
+        </p:txBody>
+      </p:sp>
+      <p:sp>
+        <p:nvSpPr>
+          <p:cNvPr id="8" name="Rounded Rectangle 7"/>
+          <p:cNvSpPr/>
+          <p:nvPr/>
+        </p:nvSpPr>
+        <p:spPr>
+          <a:xfrm>
+            <a:off x="457200" y="2020824"/>
+            <a:ext cx="3063240" cy="566928"/>
+          </a:xfrm>
+          <a:prstGeom prst="roundRect">
+            <a:avLst/>
+          </a:prstGeom>
+          <a:solidFill>
+            <a:srgbClr val="550055"/>
+          </a:solidFill>
+          <a:ln>
+            <a:noFill/>
+          </a:ln>
+          <a:effectLst/>
+        </p:spPr>
+        <p:style>
+          <a:lnRef idx="1">
+            <a:schemeClr val="accent1"/>
+          </a:lnRef>
+          <a:fillRef idx="3">
+            <a:schemeClr val="accent1"/>
+          </a:fillRef>
+          <a:effectRef idx="2">
+            <a:schemeClr val="accent1"/>
+          </a:effectRef>
+          <a:fontRef idx="minor">
+            <a:schemeClr val="lt1"/>
+          </a:fontRef>
+        </p:style>
+        <p:txBody>
+          <a:bodyPr rtlCol="0" anchor="ctr" wrap="square" lIns="128016"/>
+          <a:lstStyle/>
+          <a:p>
+            <a:pPr algn="ctr"/>
+            <a:r>
+              <a:rPr sz="1300" b="1">
+                <a:solidFill>
+                  <a:srgbClr val="FFFFFF"/>
+                </a:solidFill>
+              </a:rPr>
+              <a:t>Experience</a:t>
+            </a:r>
+          </a:p>
+        </p:txBody>
+      </p:sp>
+      <p:sp>
+        <p:nvSpPr>
+          <p:cNvPr id="9" name="Rounded Rectangle 8"/>
+          <p:cNvSpPr/>
+          <p:nvPr/>
+        </p:nvSpPr>
+        <p:spPr>
+          <a:xfrm>
+            <a:off x="3639312" y="2020824"/>
+            <a:ext cx="8092440" cy="566928"/>
+          </a:xfrm>
+          <a:prstGeom prst="roundRect">
+            <a:avLst/>
+          </a:prstGeom>
+          <a:solidFill>
+            <a:srgbClr val="F4EFF7"/>
+          </a:solidFill>
+          <a:ln w="6350">
+            <a:solidFill>
+              <a:srgbClr val="E6E3EC"/>
+            </a:solidFill>
+          </a:ln>
+          <a:effectLst/>
+        </p:spPr>
+        <p:style>
+          <a:lnRef idx="1">
+            <a:schemeClr val="accent1"/>
+          </a:lnRef>
+          <a:fillRef idx="3">
+            <a:schemeClr val="accent1"/>
+          </a:fillRef>
+          <a:effectRef idx="2">
+            <a:schemeClr val="accent1"/>
+          </a:effectRef>
+          <a:fontRef idx="minor">
+            <a:schemeClr val="lt1"/>
+          </a:fontRef>
+        </p:style>
+        <p:txBody>
+          <a:bodyPr rtlCol="0" anchor="ctr" wrap="square" lIns="146304"/>
+          <a:lstStyle/>
+          <a:p>
+            <a:pPr algn="ctr"/>
+            <a:r>
+              <a:rPr sz="1250">
                 <a:solidFill>
                   <a:srgbClr val="48484F"/>
                 </a:solidFill>
               </a:rPr>
-              <a:t>LangGraph routes each request to specialist agents; every step is traced to Langfuse.</a:t>
-            </a:r>
-          </a:p>
-          <a:p>
-            <a:pPr>
-              <a:spcAft>
-                <a:spcPts val="900"/>
-              </a:spcAft>
-            </a:pPr>
-            <a:r>
-              <a:rPr sz="1600">
-                <a:solidFill>
-                  <a:srgbClr val="BA2A84"/>
-                </a:solidFill>
-              </a:rPr>
-              <a:t>•  </a:t>
-            </a:r>
-            <a:r>
-              <a:rPr sz="1600" b="0">
+              <a:t>FastHTML app on Azure Container Apps (Docker)</a:t>
+            </a:r>
+          </a:p>
+        </p:txBody>
+      </p:sp>
+      <p:sp>
+        <p:nvSpPr>
+          <p:cNvPr id="10" name="Rounded Rectangle 9"/>
+          <p:cNvSpPr/>
+          <p:nvPr/>
+        </p:nvSpPr>
+        <p:spPr>
+          <a:xfrm>
+            <a:off x="457200" y="2670048"/>
+            <a:ext cx="3063240" cy="566928"/>
+          </a:xfrm>
+          <a:prstGeom prst="roundRect">
+            <a:avLst/>
+          </a:prstGeom>
+          <a:solidFill>
+            <a:srgbClr val="550055"/>
+          </a:solidFill>
+          <a:ln>
+            <a:noFill/>
+          </a:ln>
+          <a:effectLst/>
+        </p:spPr>
+        <p:style>
+          <a:lnRef idx="1">
+            <a:schemeClr val="accent1"/>
+          </a:lnRef>
+          <a:fillRef idx="3">
+            <a:schemeClr val="accent1"/>
+          </a:fillRef>
+          <a:effectRef idx="2">
+            <a:schemeClr val="accent1"/>
+          </a:effectRef>
+          <a:fontRef idx="minor">
+            <a:schemeClr val="lt1"/>
+          </a:fontRef>
+        </p:style>
+        <p:txBody>
+          <a:bodyPr rtlCol="0" anchor="ctr" wrap="square" lIns="128016"/>
+          <a:lstStyle/>
+          <a:p>
+            <a:pPr algn="ctr"/>
+            <a:r>
+              <a:rPr sz="1300" b="1">
+                <a:solidFill>
+                  <a:srgbClr val="FFFFFF"/>
+                </a:solidFill>
+              </a:rPr>
+              <a:t>Orchestration &amp; skills</a:t>
+            </a:r>
+          </a:p>
+        </p:txBody>
+      </p:sp>
+      <p:sp>
+        <p:nvSpPr>
+          <p:cNvPr id="11" name="Rounded Rectangle 10"/>
+          <p:cNvSpPr/>
+          <p:nvPr/>
+        </p:nvSpPr>
+        <p:spPr>
+          <a:xfrm>
+            <a:off x="3639312" y="2670048"/>
+            <a:ext cx="8092440" cy="566928"/>
+          </a:xfrm>
+          <a:prstGeom prst="roundRect">
+            <a:avLst/>
+          </a:prstGeom>
+          <a:solidFill>
+            <a:srgbClr val="F4EFF7"/>
+          </a:solidFill>
+          <a:ln w="6350">
+            <a:solidFill>
+              <a:srgbClr val="E6E3EC"/>
+            </a:solidFill>
+          </a:ln>
+          <a:effectLst/>
+        </p:spPr>
+        <p:style>
+          <a:lnRef idx="1">
+            <a:schemeClr val="accent1"/>
+          </a:lnRef>
+          <a:fillRef idx="3">
+            <a:schemeClr val="accent1"/>
+          </a:fillRef>
+          <a:effectRef idx="2">
+            <a:schemeClr val="accent1"/>
+          </a:effectRef>
+          <a:fontRef idx="minor">
+            <a:schemeClr val="lt1"/>
+          </a:fontRef>
+        </p:style>
+        <p:txBody>
+          <a:bodyPr rtlCol="0" anchor="ctr" wrap="square" lIns="146304"/>
+          <a:lstStyle/>
+          <a:p>
+            <a:pPr algn="ctr"/>
+            <a:r>
+              <a:rPr sz="1250">
                 <a:solidFill>
                   <a:srgbClr val="48484F"/>
                 </a:solidFill>
               </a:rPr>
-              <a:t>LLM calls hit Azure AI Foundry via the OpenAI-compatible endpoint — Anthropic Claude by default, swappable per-agent.</a:t>
-            </a:r>
-          </a:p>
-          <a:p>
-            <a:pPr>
-              <a:spcAft>
-                <a:spcPts val="900"/>
-              </a:spcAft>
-            </a:pPr>
-            <a:r>
-              <a:rPr sz="1600">
-                <a:solidFill>
-                  <a:srgbClr val="BA2A84"/>
-                </a:solidFill>
-              </a:rPr>
-              <a:t>•  </a:t>
-            </a:r>
-            <a:r>
-              <a:rPr sz="1600" b="0">
+              <a:t>LangGraph + skill packs — single family office lead · tax · project management</a:t>
+            </a:r>
+          </a:p>
+        </p:txBody>
+      </p:sp>
+      <p:sp>
+        <p:nvSpPr>
+          <p:cNvPr id="12" name="Rounded Rectangle 11"/>
+          <p:cNvSpPr/>
+          <p:nvPr/>
+        </p:nvSpPr>
+        <p:spPr>
+          <a:xfrm>
+            <a:off x="457200" y="3319272"/>
+            <a:ext cx="3063240" cy="566928"/>
+          </a:xfrm>
+          <a:prstGeom prst="roundRect">
+            <a:avLst/>
+          </a:prstGeom>
+          <a:solidFill>
+            <a:srgbClr val="550055"/>
+          </a:solidFill>
+          <a:ln>
+            <a:noFill/>
+          </a:ln>
+          <a:effectLst/>
+        </p:spPr>
+        <p:style>
+          <a:lnRef idx="1">
+            <a:schemeClr val="accent1"/>
+          </a:lnRef>
+          <a:fillRef idx="3">
+            <a:schemeClr val="accent1"/>
+          </a:fillRef>
+          <a:effectRef idx="2">
+            <a:schemeClr val="accent1"/>
+          </a:effectRef>
+          <a:fontRef idx="minor">
+            <a:schemeClr val="lt1"/>
+          </a:fontRef>
+        </p:style>
+        <p:txBody>
+          <a:bodyPr rtlCol="0" anchor="ctr" wrap="square" lIns="128016"/>
+          <a:lstStyle/>
+          <a:p>
+            <a:pPr algn="ctr"/>
+            <a:r>
+              <a:rPr sz="1300" b="1">
+                <a:solidFill>
+                  <a:srgbClr val="FFFFFF"/>
+                </a:solidFill>
+              </a:rPr>
+              <a:t>Tools &amp; data (MCP)</a:t>
+            </a:r>
+          </a:p>
+        </p:txBody>
+      </p:sp>
+      <p:sp>
+        <p:nvSpPr>
+          <p:cNvPr id="13" name="Rounded Rectangle 12"/>
+          <p:cNvSpPr/>
+          <p:nvPr/>
+        </p:nvSpPr>
+        <p:spPr>
+          <a:xfrm>
+            <a:off x="3639312" y="3319272"/>
+            <a:ext cx="8092440" cy="566928"/>
+          </a:xfrm>
+          <a:prstGeom prst="roundRect">
+            <a:avLst/>
+          </a:prstGeom>
+          <a:solidFill>
+            <a:srgbClr val="F4EFF7"/>
+          </a:solidFill>
+          <a:ln w="6350">
+            <a:solidFill>
+              <a:srgbClr val="E6E3EC"/>
+            </a:solidFill>
+          </a:ln>
+          <a:effectLst/>
+        </p:spPr>
+        <p:style>
+          <a:lnRef idx="1">
+            <a:schemeClr val="accent1"/>
+          </a:lnRef>
+          <a:fillRef idx="3">
+            <a:schemeClr val="accent1"/>
+          </a:fillRef>
+          <a:effectRef idx="2">
+            <a:schemeClr val="accent1"/>
+          </a:effectRef>
+          <a:fontRef idx="minor">
+            <a:schemeClr val="lt1"/>
+          </a:fontRef>
+        </p:style>
+        <p:txBody>
+          <a:bodyPr rtlCol="0" anchor="ctr" wrap="square" lIns="146304"/>
+          <a:lstStyle/>
+          <a:p>
+            <a:pPr algn="ctr"/>
+            <a:r>
+              <a:rPr sz="1250">
                 <a:solidFill>
                   <a:srgbClr val="48484F"/>
                 </a:solidFill>
               </a:rPr>
-              <a:t>Retrieval runs over PostgreSQL (pgvector hybrid) + PDFs in Blob.</a:t>
-            </a:r>
-          </a:p>
-          <a:p>
-            <a:pPr>
-              <a:spcAft>
-                <a:spcPts val="900"/>
-              </a:spcAft>
-            </a:pPr>
-            <a:r>
-              <a:rPr sz="1600">
-                <a:solidFill>
-                  <a:srgbClr val="BA2A84"/>
-                </a:solidFill>
-              </a:rPr>
-              <a:t>•  </a:t>
-            </a:r>
-            <a:r>
-              <a:rPr sz="1600" b="0">
+              <a:t>MCP servers — portfolio · docs · CRM · filings · office · market</a:t>
+            </a:r>
+          </a:p>
+        </p:txBody>
+      </p:sp>
+      <p:sp>
+        <p:nvSpPr>
+          <p:cNvPr id="14" name="Rounded Rectangle 13"/>
+          <p:cNvSpPr/>
+          <p:nvPr/>
+        </p:nvSpPr>
+        <p:spPr>
+          <a:xfrm>
+            <a:off x="457200" y="3968496"/>
+            <a:ext cx="3063240" cy="566928"/>
+          </a:xfrm>
+          <a:prstGeom prst="roundRect">
+            <a:avLst/>
+          </a:prstGeom>
+          <a:solidFill>
+            <a:srgbClr val="550055"/>
+          </a:solidFill>
+          <a:ln>
+            <a:noFill/>
+          </a:ln>
+          <a:effectLst/>
+        </p:spPr>
+        <p:style>
+          <a:lnRef idx="1">
+            <a:schemeClr val="accent1"/>
+          </a:lnRef>
+          <a:fillRef idx="3">
+            <a:schemeClr val="accent1"/>
+          </a:fillRef>
+          <a:effectRef idx="2">
+            <a:schemeClr val="accent1"/>
+          </a:effectRef>
+          <a:fontRef idx="minor">
+            <a:schemeClr val="lt1"/>
+          </a:fontRef>
+        </p:style>
+        <p:txBody>
+          <a:bodyPr rtlCol="0" anchor="ctr" wrap="square" lIns="128016"/>
+          <a:lstStyle/>
+          <a:p>
+            <a:pPr algn="ctr"/>
+            <a:r>
+              <a:rPr sz="1300" b="1">
+                <a:solidFill>
+                  <a:srgbClr val="FFFFFF"/>
+                </a:solidFill>
+              </a:rPr>
+              <a:t>Intelligence</a:t>
+            </a:r>
+          </a:p>
+        </p:txBody>
+      </p:sp>
+      <p:sp>
+        <p:nvSpPr>
+          <p:cNvPr id="15" name="Rounded Rectangle 14"/>
+          <p:cNvSpPr/>
+          <p:nvPr/>
+        </p:nvSpPr>
+        <p:spPr>
+          <a:xfrm>
+            <a:off x="3639312" y="3968496"/>
+            <a:ext cx="8092440" cy="566928"/>
+          </a:xfrm>
+          <a:prstGeom prst="roundRect">
+            <a:avLst/>
+          </a:prstGeom>
+          <a:solidFill>
+            <a:srgbClr val="F4EFF7"/>
+          </a:solidFill>
+          <a:ln w="6350">
+            <a:solidFill>
+              <a:srgbClr val="E6E3EC"/>
+            </a:solidFill>
+          </a:ln>
+          <a:effectLst/>
+        </p:spPr>
+        <p:style>
+          <a:lnRef idx="1">
+            <a:schemeClr val="accent1"/>
+          </a:lnRef>
+          <a:fillRef idx="3">
+            <a:schemeClr val="accent1"/>
+          </a:fillRef>
+          <a:effectRef idx="2">
+            <a:schemeClr val="accent1"/>
+          </a:effectRef>
+          <a:fontRef idx="minor">
+            <a:schemeClr val="lt1"/>
+          </a:fontRef>
+        </p:style>
+        <p:txBody>
+          <a:bodyPr rtlCol="0" anchor="ctr" wrap="square" lIns="146304"/>
+          <a:lstStyle/>
+          <a:p>
+            <a:pPr algn="ctr"/>
+            <a:r>
+              <a:rPr sz="1250">
                 <a:solidFill>
                   <a:srgbClr val="48484F"/>
                 </a:solidFill>
               </a:rPr>
-              <a:t>👍/👎 feedback and LLM-judge scores flow to Langfuse and the in-app analytics for a full quality loop.</a:t>
+              <a:t>Azure AI Foundry — pluggable LLMs · Anthropic Claude default</a:t>
+            </a:r>
+          </a:p>
+        </p:txBody>
+      </p:sp>
+      <p:sp>
+        <p:nvSpPr>
+          <p:cNvPr id="16" name="Rounded Rectangle 15"/>
+          <p:cNvSpPr/>
+          <p:nvPr/>
+        </p:nvSpPr>
+        <p:spPr>
+          <a:xfrm>
+            <a:off x="457200" y="4617720"/>
+            <a:ext cx="3063240" cy="566928"/>
+          </a:xfrm>
+          <a:prstGeom prst="roundRect">
+            <a:avLst/>
+          </a:prstGeom>
+          <a:solidFill>
+            <a:srgbClr val="550055"/>
+          </a:solidFill>
+          <a:ln>
+            <a:noFill/>
+          </a:ln>
+          <a:effectLst/>
+        </p:spPr>
+        <p:style>
+          <a:lnRef idx="1">
+            <a:schemeClr val="accent1"/>
+          </a:lnRef>
+          <a:fillRef idx="3">
+            <a:schemeClr val="accent1"/>
+          </a:fillRef>
+          <a:effectRef idx="2">
+            <a:schemeClr val="accent1"/>
+          </a:effectRef>
+          <a:fontRef idx="minor">
+            <a:schemeClr val="lt1"/>
+          </a:fontRef>
+        </p:style>
+        <p:txBody>
+          <a:bodyPr rtlCol="0" anchor="ctr" wrap="square" lIns="128016"/>
+          <a:lstStyle/>
+          <a:p>
+            <a:pPr algn="ctr"/>
+            <a:r>
+              <a:rPr sz="1300" b="1">
+                <a:solidFill>
+                  <a:srgbClr val="FFFFFF"/>
+                </a:solidFill>
+              </a:rPr>
+              <a:t>Data &amp; storage</a:t>
+            </a:r>
+          </a:p>
+        </p:txBody>
+      </p:sp>
+      <p:sp>
+        <p:nvSpPr>
+          <p:cNvPr id="17" name="Rounded Rectangle 16"/>
+          <p:cNvSpPr/>
+          <p:nvPr/>
+        </p:nvSpPr>
+        <p:spPr>
+          <a:xfrm>
+            <a:off x="3639312" y="4617720"/>
+            <a:ext cx="8092440" cy="566928"/>
+          </a:xfrm>
+          <a:prstGeom prst="roundRect">
+            <a:avLst/>
+          </a:prstGeom>
+          <a:solidFill>
+            <a:srgbClr val="F4EFF7"/>
+          </a:solidFill>
+          <a:ln w="6350">
+            <a:solidFill>
+              <a:srgbClr val="E6E3EC"/>
+            </a:solidFill>
+          </a:ln>
+          <a:effectLst/>
+        </p:spPr>
+        <p:style>
+          <a:lnRef idx="1">
+            <a:schemeClr val="accent1"/>
+          </a:lnRef>
+          <a:fillRef idx="3">
+            <a:schemeClr val="accent1"/>
+          </a:fillRef>
+          <a:effectRef idx="2">
+            <a:schemeClr val="accent1"/>
+          </a:effectRef>
+          <a:fontRef idx="minor">
+            <a:schemeClr val="lt1"/>
+          </a:fontRef>
+        </p:style>
+        <p:txBody>
+          <a:bodyPr rtlCol="0" anchor="ctr" wrap="square" lIns="146304"/>
+          <a:lstStyle/>
+          <a:p>
+            <a:pPr algn="ctr"/>
+            <a:r>
+              <a:rPr sz="1250">
+                <a:solidFill>
+                  <a:srgbClr val="48484F"/>
+                </a:solidFill>
+              </a:rPr>
+              <a:t>PostgreSQL (pgvector / Apache AGE) · Blob · Key Vault</a:t>
+            </a:r>
+          </a:p>
+        </p:txBody>
+      </p:sp>
+      <p:sp>
+        <p:nvSpPr>
+          <p:cNvPr id="18" name="Rounded Rectangle 17"/>
+          <p:cNvSpPr/>
+          <p:nvPr/>
+        </p:nvSpPr>
+        <p:spPr>
+          <a:xfrm>
+            <a:off x="457200" y="5266944"/>
+            <a:ext cx="3063240" cy="566928"/>
+          </a:xfrm>
+          <a:prstGeom prst="roundRect">
+            <a:avLst/>
+          </a:prstGeom>
+          <a:solidFill>
+            <a:srgbClr val="550055"/>
+          </a:solidFill>
+          <a:ln>
+            <a:noFill/>
+          </a:ln>
+          <a:effectLst/>
+        </p:spPr>
+        <p:style>
+          <a:lnRef idx="1">
+            <a:schemeClr val="accent1"/>
+          </a:lnRef>
+          <a:fillRef idx="3">
+            <a:schemeClr val="accent1"/>
+          </a:fillRef>
+          <a:effectRef idx="2">
+            <a:schemeClr val="accent1"/>
+          </a:effectRef>
+          <a:fontRef idx="minor">
+            <a:schemeClr val="lt1"/>
+          </a:fontRef>
+        </p:style>
+        <p:txBody>
+          <a:bodyPr rtlCol="0" anchor="ctr" wrap="square" lIns="128016"/>
+          <a:lstStyle/>
+          <a:p>
+            <a:pPr algn="ctr"/>
+            <a:r>
+              <a:rPr sz="1300" b="1">
+                <a:solidFill>
+                  <a:srgbClr val="FFFFFF"/>
+                </a:solidFill>
+              </a:rPr>
+              <a:t>Observability</a:t>
+            </a:r>
+          </a:p>
+        </p:txBody>
+      </p:sp>
+      <p:sp>
+        <p:nvSpPr>
+          <p:cNvPr id="19" name="Rounded Rectangle 18"/>
+          <p:cNvSpPr/>
+          <p:nvPr/>
+        </p:nvSpPr>
+        <p:spPr>
+          <a:xfrm>
+            <a:off x="3639312" y="5266944"/>
+            <a:ext cx="8092440" cy="566928"/>
+          </a:xfrm>
+          <a:prstGeom prst="roundRect">
+            <a:avLst/>
+          </a:prstGeom>
+          <a:solidFill>
+            <a:srgbClr val="F4EFF7"/>
+          </a:solidFill>
+          <a:ln w="6350">
+            <a:solidFill>
+              <a:srgbClr val="E6E3EC"/>
+            </a:solidFill>
+          </a:ln>
+          <a:effectLst/>
+        </p:spPr>
+        <p:style>
+          <a:lnRef idx="1">
+            <a:schemeClr val="accent1"/>
+          </a:lnRef>
+          <a:fillRef idx="3">
+            <a:schemeClr val="accent1"/>
+          </a:fillRef>
+          <a:effectRef idx="2">
+            <a:schemeClr val="accent1"/>
+          </a:effectRef>
+          <a:fontRef idx="minor">
+            <a:schemeClr val="lt1"/>
+          </a:fontRef>
+        </p:style>
+        <p:txBody>
+          <a:bodyPr rtlCol="0" anchor="ctr" wrap="square" lIns="146304"/>
+          <a:lstStyle/>
+          <a:p>
+            <a:pPr algn="ctr"/>
+            <a:r>
+              <a:rPr sz="1250">
+                <a:solidFill>
+                  <a:srgbClr val="48484F"/>
+                </a:solidFill>
+              </a:rPr>
+              <a:t>Langfuse — traces · evals · cost · user feedback</a:t>
             </a:r>
           </a:p>
         </p:txBody>
@@ -6263,7 +9245,7 @@
                   <a:srgbClr val="FFFFFF"/>
                 </a:solidFill>
               </a:rPr>
-              <a:t>JTC Group · Target AI Architecture · v2.0</a:t>
+              <a:t>JTC Group · Target AI Architecture · v2.1</a:t>
             </a:r>
           </a:p>
         </p:txBody>
@@ -6296,7 +9278,7 @@
                   <a:srgbClr val="6B1766"/>
                 </a:solidFill>
               </a:rPr>
-              <a:t>Option 1 — pros &amp; cons</a:t>
+              <a:t>Option 1 — how it flows</a:t>
             </a:r>
           </a:p>
         </p:txBody>
@@ -6322,288 +9304,119 @@
             <a:spAutoFit/>
           </a:bodyPr>
           <a:lstStyle/>
-          <a:p/>
-        </p:txBody>
-      </p:sp>
-      <p:sp>
-        <p:nvSpPr>
-          <p:cNvPr id="6" name="TextBox 5"/>
-          <p:cNvSpPr txBox="1"/>
-          <p:nvPr/>
-        </p:nvSpPr>
-        <p:spPr>
-          <a:xfrm>
-            <a:off x="457200" y="1280160"/>
-            <a:ext cx="5532120" cy="4937760"/>
-          </a:xfrm>
-          <a:prstGeom prst="rect">
-            <a:avLst/>
-          </a:prstGeom>
-          <a:noFill/>
-        </p:spPr>
-        <p:txBody>
-          <a:bodyPr wrap="square">
-            <a:spAutoFit/>
-          </a:bodyPr>
-          <a:lstStyle/>
           <a:p>
             <a:pPr>
               <a:spcAft>
-                <a:spcPts val="800"/>
+                <a:spcPts val="900"/>
               </a:spcAft>
             </a:pPr>
             <a:r>
-              <a:rPr sz="1900" b="1">
-                <a:solidFill>
-                  <a:srgbClr val="1C7C44"/>
-                </a:solidFill>
-              </a:rPr>
-              <a:t>Pros</a:t>
+              <a:rPr sz="1600">
+                <a:solidFill>
+                  <a:srgbClr val="BA2A84"/>
+                </a:solidFill>
+              </a:rPr>
+              <a:t>•  </a:t>
+            </a:r>
+            <a:r>
+              <a:rPr sz="1600" b="0">
+                <a:solidFill>
+                  <a:srgbClr val="48484F"/>
+                </a:solidFill>
+              </a:rPr>
+              <a:t>User → Container Apps (FastHTML) over HTTPS with Entra SSO.</a:t>
             </a:r>
           </a:p>
           <a:p>
             <a:pPr>
               <a:spcAft>
-                <a:spcPts val="700"/>
+                <a:spcPts val="900"/>
               </a:spcAft>
             </a:pPr>
             <a:r>
-              <a:rPr sz="1400" b="1">
-                <a:solidFill>
-                  <a:srgbClr val="1C7C44"/>
-                </a:solidFill>
-              </a:rPr>
-              <a:t>✓  </a:t>
-            </a:r>
-            <a:r>
-              <a:rPr sz="1400">
+              <a:rPr sz="1600">
+                <a:solidFill>
+                  <a:srgbClr val="BA2A84"/>
+                </a:solidFill>
+              </a:rPr>
+              <a:t>•  </a:t>
+            </a:r>
+            <a:r>
+              <a:rPr sz="1600" b="0">
                 <a:solidFill>
                   <a:srgbClr val="48484F"/>
                 </a:solidFill>
               </a:rPr>
-              <a:t>No lock-in — portable across Azure, other clouds, or on-prem.</a:t>
+              <a:t>LangGraph routes each request to specialist agents; every step is traced to Langfuse.</a:t>
             </a:r>
           </a:p>
           <a:p>
             <a:pPr>
               <a:spcAft>
-                <a:spcPts val="700"/>
+                <a:spcPts val="900"/>
               </a:spcAft>
             </a:pPr>
             <a:r>
-              <a:rPr sz="1400" b="1">
-                <a:solidFill>
-                  <a:srgbClr val="1C7C44"/>
-                </a:solidFill>
-              </a:rPr>
-              <a:t>✓  </a:t>
-            </a:r>
-            <a:r>
-              <a:rPr sz="1400">
+              <a:rPr sz="1600">
+                <a:solidFill>
+                  <a:srgbClr val="BA2A84"/>
+                </a:solidFill>
+              </a:rPr>
+              <a:t>•  </a:t>
+            </a:r>
+            <a:r>
+              <a:rPr sz="1600" b="0">
                 <a:solidFill>
                   <a:srgbClr val="48484F"/>
                 </a:solidFill>
               </a:rPr>
-              <a:t>Truly pluggable LLMs: Anthropic default, swap freely; no single-vendor model risk.</a:t>
+              <a:t>LLM calls hit Azure AI Foundry via the OpenAI-compatible endpoint — Anthropic Claude by default, swappable per-agent.</a:t>
             </a:r>
           </a:p>
           <a:p>
             <a:pPr>
               <a:spcAft>
-                <a:spcPts val="700"/>
+                <a:spcPts val="900"/>
               </a:spcAft>
             </a:pPr>
             <a:r>
-              <a:rPr sz="1400" b="1">
-                <a:solidFill>
-                  <a:srgbClr val="1C7C44"/>
-                </a:solidFill>
-              </a:rPr>
-              <a:t>✓  </a:t>
-            </a:r>
-            <a:r>
-              <a:rPr sz="1400">
+              <a:rPr sz="1600">
+                <a:solidFill>
+                  <a:srgbClr val="BA2A84"/>
+                </a:solidFill>
+              </a:rPr>
+              <a:t>•  </a:t>
+            </a:r>
+            <a:r>
+              <a:rPr sz="1600" b="0">
                 <a:solidFill>
                   <a:srgbClr val="48484F"/>
                 </a:solidFill>
               </a:rPr>
-              <a:t>Reuses the existing codebase (LangGraph, pluggable storage) — minimal rework.</a:t>
+              <a:t>Retrieval runs over PostgreSQL (pgvector hybrid) + PDFs in Blob.</a:t>
             </a:r>
           </a:p>
           <a:p>
             <a:pPr>
               <a:spcAft>
-                <a:spcPts val="700"/>
+                <a:spcPts val="900"/>
               </a:spcAft>
             </a:pPr>
             <a:r>
-              <a:rPr sz="1400" b="1">
-                <a:solidFill>
-                  <a:srgbClr val="1C7C44"/>
-                </a:solidFill>
-              </a:rPr>
-              <a:t>✓  </a:t>
-            </a:r>
-            <a:r>
-              <a:rPr sz="1400">
+              <a:rPr sz="1600">
+                <a:solidFill>
+                  <a:srgbClr val="BA2A84"/>
+                </a:solidFill>
+              </a:rPr>
+              <a:t>•  </a:t>
+            </a:r>
+            <a:r>
+              <a:rPr sz="1600" b="0">
                 <a:solidFill>
                   <a:srgbClr val="48484F"/>
                 </a:solidFill>
               </a:rPr>
-              <a:t>Open-source observability you own (Langfuse) — full trace/eval/cost data.</a:t>
-            </a:r>
-          </a:p>
-          <a:p>
-            <a:pPr>
-              <a:spcAft>
-                <a:spcPts val="700"/>
-              </a:spcAft>
-            </a:pPr>
-            <a:r>
-              <a:rPr sz="1400" b="1">
-                <a:solidFill>
-                  <a:srgbClr val="1C7C44"/>
-                </a:solidFill>
-              </a:rPr>
-              <a:t>✓  </a:t>
-            </a:r>
-            <a:r>
-              <a:rPr sz="1400">
-                <a:solidFill>
-                  <a:srgbClr val="48484F"/>
-                </a:solidFill>
-              </a:rPr>
-              <a:t>Transparent usage-based cost; scale each component independently.</a:t>
-            </a:r>
-          </a:p>
-        </p:txBody>
-      </p:sp>
-      <p:sp>
-        <p:nvSpPr>
-          <p:cNvPr id="7" name="TextBox 6"/>
-          <p:cNvSpPr txBox="1"/>
-          <p:nvPr/>
-        </p:nvSpPr>
-        <p:spPr>
-          <a:xfrm>
-            <a:off x="6263640" y="1280160"/>
-            <a:ext cx="5532120" cy="4937760"/>
-          </a:xfrm>
-          <a:prstGeom prst="rect">
-            <a:avLst/>
-          </a:prstGeom>
-          <a:noFill/>
-        </p:spPr>
-        <p:txBody>
-          <a:bodyPr wrap="square">
-            <a:spAutoFit/>
-          </a:bodyPr>
-          <a:lstStyle/>
-          <a:p>
-            <a:pPr>
-              <a:spcAft>
-                <a:spcPts val="800"/>
-              </a:spcAft>
-            </a:pPr>
-            <a:r>
-              <a:rPr sz="1900" b="1">
-                <a:solidFill>
-                  <a:srgbClr val="B0353A"/>
-                </a:solidFill>
-              </a:rPr>
-              <a:t>Cons</a:t>
-            </a:r>
-          </a:p>
-          <a:p>
-            <a:pPr>
-              <a:spcAft>
-                <a:spcPts val="700"/>
-              </a:spcAft>
-            </a:pPr>
-            <a:r>
-              <a:rPr sz="1400" b="1">
-                <a:solidFill>
-                  <a:srgbClr val="B0353A"/>
-                </a:solidFill>
-              </a:rPr>
-              <a:t>✕  </a:t>
-            </a:r>
-            <a:r>
-              <a:rPr sz="1400">
-                <a:solidFill>
-                  <a:srgbClr val="48484F"/>
-                </a:solidFill>
-              </a:rPr>
-              <a:t>More moving parts to operate (Container Apps, Postgres, Langfuse).</a:t>
-            </a:r>
-          </a:p>
-          <a:p>
-            <a:pPr>
-              <a:spcAft>
-                <a:spcPts val="700"/>
-              </a:spcAft>
-            </a:pPr>
-            <a:r>
-              <a:rPr sz="1400" b="1">
-                <a:solidFill>
-                  <a:srgbClr val="B0353A"/>
-                </a:solidFill>
-              </a:rPr>
-              <a:t>✕  </a:t>
-            </a:r>
-            <a:r>
-              <a:rPr sz="1400">
-                <a:solidFill>
-                  <a:srgbClr val="48484F"/>
-                </a:solidFill>
-              </a:rPr>
-              <a:t>You own upgrades, scaling &amp; backups — eased by managed PaaS.</a:t>
-            </a:r>
-          </a:p>
-          <a:p>
-            <a:pPr>
-              <a:spcAft>
-                <a:spcPts val="700"/>
-              </a:spcAft>
-            </a:pPr>
-            <a:r>
-              <a:rPr sz="1400" b="1">
-                <a:solidFill>
-                  <a:srgbClr val="B0353A"/>
-                </a:solidFill>
-              </a:rPr>
-              <a:t>✕  </a:t>
-            </a:r>
-            <a:r>
-              <a:rPr sz="1400">
-                <a:solidFill>
-                  <a:srgbClr val="48484F"/>
-                </a:solidFill>
-              </a:rPr>
-              <a:t>Graph queries need pgvector/Apache AGE, or a managed Neo4j AuraDB add-on.</a:t>
-            </a:r>
-          </a:p>
-          <a:p>
-            <a:pPr>
-              <a:spcAft>
-                <a:spcPts val="700"/>
-              </a:spcAft>
-            </a:pPr>
-            <a:r>
-              <a:rPr sz="1400" b="1">
-                <a:solidFill>
-                  <a:srgbClr val="B0353A"/>
-                </a:solidFill>
-              </a:rPr>
-              <a:t>✕  </a:t>
-            </a:r>
-            <a:r>
-              <a:rPr sz="1400">
-                <a:solidFill>
-                  <a:srgbClr val="48484F"/>
-                </a:solidFill>
-              </a:rPr>
-              <a:t>Langfuse is another service to run (or pay for Langfuse Cloud).</a:t>
+              <a:t>👍/👎 feedback and LLM-judge scores flow to Langfuse and the in-app analytics for a full quality loop.</a:t>
             </a:r>
           </a:p>
         </p:txBody>
@@ -6717,7 +9530,7 @@
                   <a:srgbClr val="FFFFFF"/>
                 </a:solidFill>
               </a:rPr>
-              <a:t>JTC Group · Target AI Architecture · v2.0</a:t>
+              <a:t>JTC Group · Target AI Architecture · v2.1</a:t>
             </a:r>
           </a:p>
         </p:txBody>
@@ -6750,15 +9563,7 @@
                   <a:srgbClr val="6B1766"/>
                 </a:solidFill>
               </a:rPr>
-              <a:t>Option 2 — Microsoft-managed</a:t>
-            </a:r>
-            <a:r>
-              <a:rPr sz="1300" b="1">
-                <a:solidFill>
-                  <a:srgbClr val="BA2A84"/>
-                </a:solidFill>
-              </a:rPr>
-              <a:t>   MANAGED</a:t>
+              <a:t>Option 1 — pros &amp; cons</a:t>
             </a:r>
           </a:p>
         </p:txBody>
@@ -6784,19 +9589,43 @@
             <a:spAutoFit/>
           </a:bodyPr>
           <a:lstStyle/>
+          <a:p/>
+        </p:txBody>
+      </p:sp>
+      <p:sp>
+        <p:nvSpPr>
+          <p:cNvPr id="6" name="TextBox 5"/>
+          <p:cNvSpPr txBox="1"/>
+          <p:nvPr/>
+        </p:nvSpPr>
+        <p:spPr>
+          <a:xfrm>
+            <a:off x="457200" y="1280160"/>
+            <a:ext cx="5532120" cy="4937760"/>
+          </a:xfrm>
+          <a:prstGeom prst="rect">
+            <a:avLst/>
+          </a:prstGeom>
+          <a:noFill/>
+        </p:spPr>
+        <p:txBody>
+          <a:bodyPr wrap="square">
+            <a:spAutoFit/>
+          </a:bodyPr>
+          <a:lstStyle/>
           <a:p>
             <a:pPr>
               <a:spcAft>
-                <a:spcPts val="1200"/>
+                <a:spcPts val="800"/>
               </a:spcAft>
             </a:pPr>
             <a:r>
-              <a:rPr sz="1500" b="0">
-                <a:solidFill>
-                  <a:srgbClr val="48484F"/>
-                </a:solidFill>
-              </a:rPr>
-              <a:t>Foundry Agent Service + Microsoft Fabric — least ops, deepest Microsoft integration, at the cost of portability.</a:t>
+              <a:rPr sz="1900" b="1">
+                <a:solidFill>
+                  <a:srgbClr val="1C7C44"/>
+                </a:solidFill>
+              </a:rPr>
+              <a:t>Pros</a:t>
             </a:r>
           </a:p>
           <a:p>
@@ -6806,12 +9635,12 @@
               </a:spcAft>
             </a:pPr>
             <a:r>
-              <a:rPr sz="1500" b="1">
-                <a:solidFill>
-                  <a:srgbClr val="550055"/>
-                </a:solidFill>
-              </a:rPr>
-              <a:t>Azure AI Foundry Agent Service  —  </a:t>
+              <a:rPr sz="1400" b="1">
+                <a:solidFill>
+                  <a:srgbClr val="1C7C44"/>
+                </a:solidFill>
+              </a:rPr>
+              <a:t>✓  </a:t>
             </a:r>
             <a:r>
               <a:rPr sz="1400">
@@ -6819,7 +9648,7 @@
                   <a:srgbClr val="48484F"/>
                 </a:solidFill>
               </a:rPr>
-              <a:t>Managed agents, built-in tool-calling, threads &amp; multi-agent orchestration (replaces custom LangGraph)</a:t>
+              <a:t>No lock-in — portable across Azure, other clouds, or on-prem.</a:t>
             </a:r>
           </a:p>
           <a:p>
@@ -6829,12 +9658,12 @@
               </a:spcAft>
             </a:pPr>
             <a:r>
-              <a:rPr sz="1500" b="1">
-                <a:solidFill>
-                  <a:srgbClr val="550055"/>
-                </a:solidFill>
-              </a:rPr>
-              <a:t>Skills as connected agents  —  </a:t>
+              <a:rPr sz="1400" b="1">
+                <a:solidFill>
+                  <a:srgbClr val="1C7C44"/>
+                </a:solidFill>
+              </a:rPr>
+              <a:t>✓  </a:t>
             </a:r>
             <a:r>
               <a:rPr sz="1400">
@@ -6842,7 +9671,7 @@
                   <a:srgbClr val="48484F"/>
                 </a:solidFill>
               </a:rPr>
-              <a:t>SFO-lead / tax / project-management skill packs map to Foundry connected agents &amp; tool sets</a:t>
+              <a:t>Truly pluggable LLMs: Anthropic default, swap freely; no single-vendor model risk.</a:t>
             </a:r>
           </a:p>
           <a:p>
@@ -6852,12 +9681,12 @@
               </a:spcAft>
             </a:pPr>
             <a:r>
-              <a:rPr sz="1500" b="1">
-                <a:solidFill>
-                  <a:srgbClr val="550055"/>
-                </a:solidFill>
-              </a:rPr>
-              <a:t>MCP tools in Foundry  —  </a:t>
+              <a:rPr sz="1400" b="1">
+                <a:solidFill>
+                  <a:srgbClr val="1C7C44"/>
+                </a:solidFill>
+              </a:rPr>
+              <a:t>✓  </a:t>
             </a:r>
             <a:r>
               <a:rPr sz="1400">
@@ -6865,7 +9694,7 @@
                   <a:srgbClr val="48484F"/>
                 </a:solidFill>
               </a:rPr>
-              <a:t>Foundry Agent Service consumes the same MCP servers as managed tools</a:t>
+              <a:t>Reuses the existing codebase (LangGraph, pluggable storage) — minimal rework.</a:t>
             </a:r>
           </a:p>
           <a:p>
@@ -6875,12 +9704,12 @@
               </a:spcAft>
             </a:pPr>
             <a:r>
-              <a:rPr sz="1500" b="1">
-                <a:solidFill>
-                  <a:srgbClr val="550055"/>
-                </a:solidFill>
-              </a:rPr>
-              <a:t>Azure AI Search  —  </a:t>
+              <a:rPr sz="1400" b="1">
+                <a:solidFill>
+                  <a:srgbClr val="1C7C44"/>
+                </a:solidFill>
+              </a:rPr>
+              <a:t>✓  </a:t>
             </a:r>
             <a:r>
               <a:rPr sz="1400">
@@ -6888,7 +9717,7 @@
                   <a:srgbClr val="48484F"/>
                 </a:solidFill>
               </a:rPr>
-              <a:t>Managed vector + hybrid RAG over the corpus</a:t>
+              <a:t>Open-source observability you own (Langfuse) — full trace/eval/cost data.</a:t>
             </a:r>
           </a:p>
           <a:p>
@@ -6898,12 +9727,12 @@
               </a:spcAft>
             </a:pPr>
             <a:r>
-              <a:rPr sz="1500" b="1">
-                <a:solidFill>
-                  <a:srgbClr val="550055"/>
-                </a:solidFill>
-              </a:rPr>
-              <a:t>Microsoft Fabric (OneLake)  —  </a:t>
+              <a:rPr sz="1400" b="1">
+                <a:solidFill>
+                  <a:srgbClr val="1C7C44"/>
+                </a:solidFill>
+              </a:rPr>
+              <a:t>✓  </a:t>
             </a:r>
             <a:r>
               <a:rPr sz="1400">
@@ -6911,7 +9740,45 @@
                   <a:srgbClr val="48484F"/>
                 </a:solidFill>
               </a:rPr>
-              <a:t>Unified data lake for tax docs · Lakehouse / Warehouse · Data Factory ingestion pipelines</a:t>
+              <a:t>Transparent usage-based cost; scale each component independently.</a:t>
+            </a:r>
+          </a:p>
+        </p:txBody>
+      </p:sp>
+      <p:sp>
+        <p:nvSpPr>
+          <p:cNvPr id="7" name="TextBox 6"/>
+          <p:cNvSpPr txBox="1"/>
+          <p:nvPr/>
+        </p:nvSpPr>
+        <p:spPr>
+          <a:xfrm>
+            <a:off x="6263640" y="1280160"/>
+            <a:ext cx="5532120" cy="4937760"/>
+          </a:xfrm>
+          <a:prstGeom prst="rect">
+            <a:avLst/>
+          </a:prstGeom>
+          <a:noFill/>
+        </p:spPr>
+        <p:txBody>
+          <a:bodyPr wrap="square">
+            <a:spAutoFit/>
+          </a:bodyPr>
+          <a:lstStyle/>
+          <a:p>
+            <a:pPr>
+              <a:spcAft>
+                <a:spcPts val="800"/>
+              </a:spcAft>
+            </a:pPr>
+            <a:r>
+              <a:rPr sz="1900" b="1">
+                <a:solidFill>
+                  <a:srgbClr val="B0353A"/>
+                </a:solidFill>
+              </a:rPr>
+              <a:t>Cons</a:t>
             </a:r>
           </a:p>
           <a:p>
@@ -6921,12 +9788,12 @@
               </a:spcAft>
             </a:pPr>
             <a:r>
-              <a:rPr sz="1500" b="1">
-                <a:solidFill>
-                  <a:srgbClr val="550055"/>
-                </a:solidFill>
-              </a:rPr>
-              <a:t>Power BI  —  </a:t>
+              <a:rPr sz="1400" b="1">
+                <a:solidFill>
+                  <a:srgbClr val="B0353A"/>
+                </a:solidFill>
+              </a:rPr>
+              <a:t>✕  </a:t>
             </a:r>
             <a:r>
               <a:rPr sz="1400">
@@ -6934,7 +9801,7 @@
                   <a:srgbClr val="48484F"/>
                 </a:solidFill>
               </a:rPr>
-              <a:t>Firmwide compliance &amp; filing dashboards on Fabric data</a:t>
+              <a:t>More moving parts to operate (Container Apps, Postgres, Langfuse).</a:t>
             </a:r>
           </a:p>
           <a:p>
@@ -6944,12 +9811,12 @@
               </a:spcAft>
             </a:pPr>
             <a:r>
-              <a:rPr sz="1500" b="1">
-                <a:solidFill>
-                  <a:srgbClr val="550055"/>
-                </a:solidFill>
-              </a:rPr>
-              <a:t>Azure OpenAI (GPT)  —  </a:t>
+              <a:rPr sz="1400" b="1">
+                <a:solidFill>
+                  <a:srgbClr val="B0353A"/>
+                </a:solidFill>
+              </a:rPr>
+              <a:t>✕  </a:t>
             </a:r>
             <a:r>
               <a:rPr sz="1400">
@@ -6957,7 +9824,7 @@
                   <a:srgbClr val="48484F"/>
                 </a:solidFill>
               </a:rPr>
-              <a:t>Default models; Anthropic Claude also available in the Foundry catalog</a:t>
+              <a:t>You own upgrades, scaling &amp; backups — eased by managed PaaS.</a:t>
             </a:r>
           </a:p>
           <a:p>
@@ -6967,12 +9834,12 @@
               </a:spcAft>
             </a:pPr>
             <a:r>
-              <a:rPr sz="1500" b="1">
-                <a:solidFill>
-                  <a:srgbClr val="550055"/>
-                </a:solidFill>
-              </a:rPr>
-              <a:t>Azure Monitor + Foundry evaluations  —  </a:t>
+              <a:rPr sz="1400" b="1">
+                <a:solidFill>
+                  <a:srgbClr val="B0353A"/>
+                </a:solidFill>
+              </a:rPr>
+              <a:t>✕  </a:t>
             </a:r>
             <a:r>
               <a:rPr sz="1400">
@@ -6980,7 +9847,7 @@
                   <a:srgbClr val="48484F"/>
                 </a:solidFill>
               </a:rPr>
-              <a:t>Built-in tracing &amp; evaluation</a:t>
+              <a:t>Graph queries need pgvector/Apache AGE, or a managed Neo4j AuraDB add-on.</a:t>
             </a:r>
           </a:p>
           <a:p>
@@ -6990,12 +9857,12 @@
               </a:spcAft>
             </a:pPr>
             <a:r>
-              <a:rPr sz="1500" b="1">
-                <a:solidFill>
-                  <a:srgbClr val="550055"/>
-                </a:solidFill>
-              </a:rPr>
-              <a:t>Microsoft Purview  —  </a:t>
+              <a:rPr sz="1400" b="1">
+                <a:solidFill>
+                  <a:srgbClr val="B0353A"/>
+                </a:solidFill>
+              </a:rPr>
+              <a:t>✕  </a:t>
             </a:r>
             <a:r>
               <a:rPr sz="1400">
@@ -7003,7 +9870,7 @@
                   <a:srgbClr val="48484F"/>
                 </a:solidFill>
               </a:rPr>
-              <a:t>Governance, data lineage &amp; DLP</a:t>
+              <a:t>Langfuse is another service to run (or pay for Langfuse Cloud).</a:t>
             </a:r>
           </a:p>
         </p:txBody>
@@ -7117,7 +9984,7 @@
                   <a:srgbClr val="FFFFFF"/>
                 </a:solidFill>
               </a:rPr>
-              <a:t>JTC Group · Target AI Architecture · v2.0</a:t>
+              <a:t>JTC Group · Target AI Architecture · v2.1</a:t>
             </a:r>
           </a:p>
         </p:txBody>
@@ -7150,7 +10017,15 @@
                   <a:srgbClr val="6B1766"/>
                 </a:solidFill>
               </a:rPr>
-              <a:t>Option 2 — pros &amp; cons</a:t>
+              <a:t>Option 2 — Microsoft-managed</a:t>
+            </a:r>
+            <a:r>
+              <a:rPr sz="1300" b="1">
+                <a:solidFill>
+                  <a:srgbClr val="BA2A84"/>
+                </a:solidFill>
+              </a:rPr>
+              <a:t>   MANAGED</a:t>
             </a:r>
           </a:p>
         </p:txBody>
@@ -7176,43 +10051,19 @@
             <a:spAutoFit/>
           </a:bodyPr>
           <a:lstStyle/>
-          <a:p/>
-        </p:txBody>
-      </p:sp>
-      <p:sp>
-        <p:nvSpPr>
-          <p:cNvPr id="6" name="TextBox 5"/>
-          <p:cNvSpPr txBox="1"/>
-          <p:nvPr/>
-        </p:nvSpPr>
-        <p:spPr>
-          <a:xfrm>
-            <a:off x="457200" y="1280160"/>
-            <a:ext cx="5532120" cy="4937760"/>
-          </a:xfrm>
-          <a:prstGeom prst="rect">
-            <a:avLst/>
-          </a:prstGeom>
-          <a:noFill/>
-        </p:spPr>
-        <p:txBody>
-          <a:bodyPr wrap="square">
-            <a:spAutoFit/>
-          </a:bodyPr>
-          <a:lstStyle/>
           <a:p>
             <a:pPr>
               <a:spcAft>
-                <a:spcPts val="800"/>
+                <a:spcPts val="1200"/>
               </a:spcAft>
             </a:pPr>
             <a:r>
-              <a:rPr sz="1900" b="1">
-                <a:solidFill>
-                  <a:srgbClr val="1C7C44"/>
-                </a:solidFill>
-              </a:rPr>
-              <a:t>Pros</a:t>
+              <a:rPr sz="1500" b="0">
+                <a:solidFill>
+                  <a:srgbClr val="48484F"/>
+                </a:solidFill>
+              </a:rPr>
+              <a:t>Foundry Agent Service + Microsoft Fabric — least ops, deepest Microsoft integration, at the cost of portability.</a:t>
             </a:r>
           </a:p>
           <a:p>
@@ -7222,12 +10073,12 @@
               </a:spcAft>
             </a:pPr>
             <a:r>
-              <a:rPr sz="1400" b="1">
-                <a:solidFill>
-                  <a:srgbClr val="1C7C44"/>
-                </a:solidFill>
-              </a:rPr>
-              <a:t>✓  </a:t>
+              <a:rPr sz="1500" b="1">
+                <a:solidFill>
+                  <a:srgbClr val="550055"/>
+                </a:solidFill>
+              </a:rPr>
+              <a:t>Azure AI Foundry Agent Service  —  </a:t>
             </a:r>
             <a:r>
               <a:rPr sz="1400">
@@ -7235,7 +10086,7 @@
                   <a:srgbClr val="48484F"/>
                 </a:solidFill>
               </a:rPr>
-              <a:t>Fully managed — least ops; Microsoft runs the agents, RAG and scaling.</a:t>
+              <a:t>Managed agents, built-in tool-calling, threads &amp; multi-agent orchestration (replaces custom LangGraph)</a:t>
             </a:r>
           </a:p>
           <a:p>
@@ -7245,12 +10096,12 @@
               </a:spcAft>
             </a:pPr>
             <a:r>
-              <a:rPr sz="1400" b="1">
-                <a:solidFill>
-                  <a:srgbClr val="1C7C44"/>
-                </a:solidFill>
-              </a:rPr>
-              <a:t>✓  </a:t>
+              <a:rPr sz="1500" b="1">
+                <a:solidFill>
+                  <a:srgbClr val="550055"/>
+                </a:solidFill>
+              </a:rPr>
+              <a:t>Skills as connected agents  —  </a:t>
             </a:r>
             <a:r>
               <a:rPr sz="1400">
@@ -7258,7 +10109,7 @@
                   <a:srgbClr val="48484F"/>
                 </a:solidFill>
               </a:rPr>
-              <a:t>Deep Microsoft integration: Entra, Purview governance, Fabric, Power BI.</a:t>
+              <a:t>SFO-lead / tax / project-management skill packs map to Foundry connected agents &amp; tool sets</a:t>
             </a:r>
           </a:p>
           <a:p>
@@ -7268,12 +10119,12 @@
               </a:spcAft>
             </a:pPr>
             <a:r>
-              <a:rPr sz="1400" b="1">
-                <a:solidFill>
-                  <a:srgbClr val="1C7C44"/>
-                </a:solidFill>
-              </a:rPr>
-              <a:t>✓  </a:t>
+              <a:rPr sz="1500" b="1">
+                <a:solidFill>
+                  <a:srgbClr val="550055"/>
+                </a:solidFill>
+              </a:rPr>
+              <a:t>MCP tools in Foundry  —  </a:t>
             </a:r>
             <a:r>
               <a:rPr sz="1400">
@@ -7281,7 +10132,7 @@
                   <a:srgbClr val="48484F"/>
                 </a:solidFill>
               </a:rPr>
-              <a:t>Enterprise SLA &amp; support — strong fit for a Microsoft-shop like JTC.</a:t>
+              <a:t>Foundry Agent Service consumes the same MCP servers as managed tools</a:t>
             </a:r>
           </a:p>
           <a:p>
@@ -7291,12 +10142,12 @@
               </a:spcAft>
             </a:pPr>
             <a:r>
-              <a:rPr sz="1400" b="1">
-                <a:solidFill>
-                  <a:srgbClr val="1C7C44"/>
-                </a:solidFill>
-              </a:rPr>
-              <a:t>✓  </a:t>
+              <a:rPr sz="1500" b="1">
+                <a:solidFill>
+                  <a:srgbClr val="550055"/>
+                </a:solidFill>
+              </a:rPr>
+              <a:t>Azure AI Search  —  </a:t>
             </a:r>
             <a:r>
               <a:rPr sz="1400">
@@ -7304,7 +10155,7 @@
                   <a:srgbClr val="48484F"/>
                 </a:solidFill>
               </a:rPr>
-              <a:t>Built-in agent orchestration, managed RAG and evaluations out of the box.</a:t>
+              <a:t>Managed vector + hybrid RAG over the corpus</a:t>
             </a:r>
           </a:p>
           <a:p>
@@ -7314,12 +10165,12 @@
               </a:spcAft>
             </a:pPr>
             <a:r>
-              <a:rPr sz="1400" b="1">
-                <a:solidFill>
-                  <a:srgbClr val="1C7C44"/>
-                </a:solidFill>
-              </a:rPr>
-              <a:t>✓  </a:t>
+              <a:rPr sz="1500" b="1">
+                <a:solidFill>
+                  <a:srgbClr val="550055"/>
+                </a:solidFill>
+              </a:rPr>
+              <a:t>Microsoft Fabric (OneLake)  —  </a:t>
             </a:r>
             <a:r>
               <a:rPr sz="1400">
@@ -7327,45 +10178,7 @@
                   <a:srgbClr val="48484F"/>
                 </a:solidFill>
               </a:rPr>
-              <a:t>Fabric unifies data + BI for firmwide reporting.</a:t>
-            </a:r>
-          </a:p>
-        </p:txBody>
-      </p:sp>
-      <p:sp>
-        <p:nvSpPr>
-          <p:cNvPr id="7" name="TextBox 6"/>
-          <p:cNvSpPr txBox="1"/>
-          <p:nvPr/>
-        </p:nvSpPr>
-        <p:spPr>
-          <a:xfrm>
-            <a:off x="6263640" y="1280160"/>
-            <a:ext cx="5532120" cy="4937760"/>
-          </a:xfrm>
-          <a:prstGeom prst="rect">
-            <a:avLst/>
-          </a:prstGeom>
-          <a:noFill/>
-        </p:spPr>
-        <p:txBody>
-          <a:bodyPr wrap="square">
-            <a:spAutoFit/>
-          </a:bodyPr>
-          <a:lstStyle/>
-          <a:p>
-            <a:pPr>
-              <a:spcAft>
-                <a:spcPts val="800"/>
-              </a:spcAft>
-            </a:pPr>
-            <a:r>
-              <a:rPr sz="1900" b="1">
-                <a:solidFill>
-                  <a:srgbClr val="B0353A"/>
-                </a:solidFill>
-              </a:rPr>
-              <a:t>Cons</a:t>
+              <a:t>Unified data lake for tax docs · Lakehouse / Warehouse · Data Factory ingestion pipelines</a:t>
             </a:r>
           </a:p>
           <a:p>
@@ -7375,12 +10188,12 @@
               </a:spcAft>
             </a:pPr>
             <a:r>
-              <a:rPr sz="1400" b="1">
-                <a:solidFill>
-                  <a:srgbClr val="B0353A"/>
-                </a:solidFill>
-              </a:rPr>
-              <a:t>✕  </a:t>
+              <a:rPr sz="1500" b="1">
+                <a:solidFill>
+                  <a:srgbClr val="550055"/>
+                </a:solidFill>
+              </a:rPr>
+              <a:t>Power BI  —  </a:t>
             </a:r>
             <a:r>
               <a:rPr sz="1400">
@@ -7388,7 +10201,7 @@
                   <a:srgbClr val="48484F"/>
                 </a:solidFill>
               </a:rPr>
-              <a:t>Vendor lock-in — Azure/Foundry/Fabric-specific; low portability.</a:t>
+              <a:t>Firmwide compliance &amp; filing dashboards on Fabric data</a:t>
             </a:r>
           </a:p>
           <a:p>
@@ -7398,12 +10211,12 @@
               </a:spcAft>
             </a:pPr>
             <a:r>
-              <a:rPr sz="1400" b="1">
-                <a:solidFill>
-                  <a:srgbClr val="B0353A"/>
-                </a:solidFill>
-              </a:rPr>
-              <a:t>✕  </a:t>
+              <a:rPr sz="1500" b="1">
+                <a:solidFill>
+                  <a:srgbClr val="550055"/>
+                </a:solidFill>
+              </a:rPr>
+              <a:t>Azure OpenAI (GPT)  —  </a:t>
             </a:r>
             <a:r>
               <a:rPr sz="1400">
@@ -7411,7 +10224,7 @@
                   <a:srgbClr val="48484F"/>
                 </a:solidFill>
               </a:rPr>
-              <a:t>Rework: migrate off LangGraph/Neo4j to Foundry Agents + Fabric.</a:t>
+              <a:t>Default models; Anthropic Claude also available in the Foundry catalog</a:t>
             </a:r>
           </a:p>
           <a:p>
@@ -7421,12 +10234,12 @@
               </a:spcAft>
             </a:pPr>
             <a:r>
-              <a:rPr sz="1400" b="1">
-                <a:solidFill>
-                  <a:srgbClr val="B0353A"/>
-                </a:solidFill>
-              </a:rPr>
-              <a:t>✕  </a:t>
+              <a:rPr sz="1500" b="1">
+                <a:solidFill>
+                  <a:srgbClr val="550055"/>
+                </a:solidFill>
+              </a:rPr>
+              <a:t>Azure Monitor + Foundry evaluations  —  </a:t>
             </a:r>
             <a:r>
               <a:rPr sz="1400">
@@ -7434,7 +10247,7 @@
                   <a:srgbClr val="48484F"/>
                 </a:solidFill>
               </a:rPr>
-              <a:t>Model choice steered to OpenAI; less control over orchestration internals.</a:t>
+              <a:t>Built-in tracing &amp; evaluation</a:t>
             </a:r>
           </a:p>
           <a:p>
@@ -7444,12 +10257,12 @@
               </a:spcAft>
             </a:pPr>
             <a:r>
-              <a:rPr sz="1400" b="1">
-                <a:solidFill>
-                  <a:srgbClr val="B0353A"/>
-                </a:solidFill>
-              </a:rPr>
-              <a:t>✕  </a:t>
+              <a:rPr sz="1500" b="1">
+                <a:solidFill>
+                  <a:srgbClr val="550055"/>
+                </a:solidFill>
+              </a:rPr>
+              <a:t>Microsoft Purview  —  </a:t>
             </a:r>
             <a:r>
               <a:rPr sz="1400">
@@ -7457,30 +10270,7 @@
                   <a:srgbClr val="48484F"/>
                 </a:solidFill>
               </a:rPr>
-              <a:t>Fabric capacity (F-SKUs) + Search + Foundry can be costly &amp; hard to predict.</a:t>
-            </a:r>
-          </a:p>
-          <a:p>
-            <a:pPr>
-              <a:spcAft>
-                <a:spcPts val="700"/>
-              </a:spcAft>
-            </a:pPr>
-            <a:r>
-              <a:rPr sz="1400" b="1">
-                <a:solidFill>
-                  <a:srgbClr val="B0353A"/>
-                </a:solidFill>
-              </a:rPr>
-              <a:t>✕  </a:t>
-            </a:r>
-            <a:r>
-              <a:rPr sz="1400">
-                <a:solidFill>
-                  <a:srgbClr val="48484F"/>
-                </a:solidFill>
-              </a:rPr>
-              <a:t>Managed-agent surface is newer and still maturing.</a:t>
+              <a:t>Governance, data lineage &amp; DLP</a:t>
             </a:r>
           </a:p>
         </p:txBody>

</xml_diff>